<commit_message>
update 08 intro slide
</commit_message>
<xml_diff>
--- a/084_final_intro_slides_2nd.pptx
+++ b/084_final_intro_slides_2nd.pptx
@@ -688,7 +688,7 @@
               <a:buNone/>
             </a:pPr>
             <a:r>
-              <a:rPr lang="en-US" sz="900" dirty="0">
+              <a:rPr lang="en-US" sz="900">
                 <a:solidFill>
                   <a:srgbClr val="6B7280"/>
                 </a:solidFill>
@@ -698,7 +698,7 @@
               </a:rPr>
               <a:t>メカトロニクス実習 第8回（2nd turn）</a:t>
             </a:r>
-            <a:endParaRPr lang="en-US" sz="900" dirty="0"/>
+            <a:endParaRPr lang="en-US" sz="900"/>
           </a:p>
         </p:txBody>
       </p:sp>
@@ -727,7 +727,7 @@
               <a:buNone/>
             </a:pPr>
             <a:r>
-              <a:rPr lang="en-US" sz="900" dirty="0">
+              <a:rPr lang="en-US" sz="900">
                 <a:solidFill>
                   <a:srgbClr val="6B7280"/>
                 </a:solidFill>
@@ -737,7 +737,7 @@
               </a:rPr>
               <a:t>AI外観検査システム</a:t>
             </a:r>
-            <a:endParaRPr lang="en-US" sz="900" dirty="0"/>
+            <a:endParaRPr lang="en-US" sz="900"/>
           </a:p>
         </p:txBody>
       </p:sp>
@@ -761,7 +761,7 @@
           </a:prstGeom>
           <a:extLst>
             <a:ext uri="{C572A759-6A51-4108-AA02-DFA0A04FC94B}">
-              <ma14:wrappingTextBoxFlag xmlns:ma14="http://schemas.microsoft.com/office/mac/drawingml/2011/main" xmlns="" val="0"/>
+              <ma14:wrappingTextBoxFlag xmlns="" xmlns:ma14="http://schemas.microsoft.com/office/mac/drawingml/2011/main" val="0"/>
             </a:ext>
           </a:extLst>
         </p:spPr>
@@ -839,7 +839,7 @@
           </a:prstGeom>
           <a:extLst>
             <a:ext uri="{C572A759-6A51-4108-AA02-DFA0A04FC94B}">
-              <ma14:wrappingTextBoxFlag xmlns:ma14="http://schemas.microsoft.com/office/mac/drawingml/2011/main" xmlns="" val="0"/>
+              <ma14:wrappingTextBoxFlag xmlns="" xmlns:ma14="http://schemas.microsoft.com/office/mac/drawingml/2011/main" val="0"/>
             </a:ext>
           </a:extLst>
         </p:spPr>
@@ -1250,39 +1250,16 @@
           </a:ln>
         </p:spPr>
         <p:txBody>
-          <a:bodyPr/>
-          <a:lstStyle/>
-          <a:p>
-            <a:endParaRPr lang="ja-JP" altLang="en-US"/>
-          </a:p>
-        </p:txBody>
-      </p:sp>
-      <p:sp>
-        <p:nvSpPr>
-          <p:cNvPr id="5" name="Text 3"/>
-          <p:cNvSpPr/>
-          <p:nvPr/>
-        </p:nvSpPr>
-        <p:spPr>
-          <a:xfrm>
-            <a:off x="1143000" y="1920240"/>
-            <a:ext cx="4251960" cy="457200"/>
-          </a:xfrm>
-          <a:prstGeom prst="rect">
-            <a:avLst/>
-          </a:prstGeom>
-          <a:noFill/>
-          <a:ln/>
-        </p:spPr>
-        <p:txBody>
-          <a:bodyPr wrap="square" lIns="0" tIns="0" rIns="0" bIns="0" rtlCol="0" anchor="ctr"/>
+          <a:bodyPr wrap="square" lIns="91440" tIns="45720" rIns="91440" bIns="45720" anchor="ctr">
+            <a:normAutofit/>
+          </a:bodyPr>
           <a:lstStyle/>
           <a:p>
             <a:pPr marL="0" indent="0" algn="ctr">
               <a:buNone/>
             </a:pPr>
             <a:r>
-              <a:rPr lang="en-US" sz="3000" b="1" dirty="0">
+              <a:rPr lang="en-US" sz="3000" b="1" dirty="0" err="1">
                 <a:solidFill>
                   <a:srgbClr val="2F75B5"/>
                 </a:solidFill>
@@ -1294,28 +1271,6 @@
             </a:r>
             <a:endParaRPr lang="en-US" sz="3000" dirty="0"/>
           </a:p>
-        </p:txBody>
-      </p:sp>
-      <p:sp>
-        <p:nvSpPr>
-          <p:cNvPr id="6" name="Text 4"/>
-          <p:cNvSpPr/>
-          <p:nvPr/>
-        </p:nvSpPr>
-        <p:spPr>
-          <a:xfrm>
-            <a:off x="1143000" y="2514600"/>
-            <a:ext cx="4251960" cy="658368"/>
-          </a:xfrm>
-          <a:prstGeom prst="rect">
-            <a:avLst/>
-          </a:prstGeom>
-          <a:noFill/>
-          <a:ln/>
-        </p:spPr>
-        <p:txBody>
-          <a:bodyPr wrap="square" lIns="0" tIns="0" rIns="0" bIns="0" rtlCol="0" anchor="ctr"/>
-          <a:lstStyle/>
           <a:p>
             <a:pPr marL="0" indent="0" algn="ctr">
               <a:buNone/>
@@ -1333,33 +1288,22 @@
             </a:r>
             <a:endParaRPr lang="en-US" sz="3800" dirty="0"/>
           </a:p>
-        </p:txBody>
-      </p:sp>
-      <p:sp>
-        <p:nvSpPr>
-          <p:cNvPr id="7" name="Text 5"/>
-          <p:cNvSpPr/>
-          <p:nvPr/>
-        </p:nvSpPr>
-        <p:spPr>
-          <a:xfrm>
-            <a:off x="1097280" y="3429000"/>
-            <a:ext cx="4389120" cy="457200"/>
-          </a:xfrm>
-          <a:prstGeom prst="rect">
-            <a:avLst/>
-          </a:prstGeom>
-          <a:noFill/>
-          <a:ln/>
-        </p:spPr>
-        <p:txBody>
-          <a:bodyPr wrap="square" lIns="0" tIns="0" rIns="0" bIns="0" rtlCol="0" anchor="ctr"/>
-          <a:lstStyle/>
           <a:p>
             <a:pPr marL="0" indent="0" algn="ctr">
               <a:buNone/>
             </a:pPr>
             <a:r>
+              <a:rPr lang="en-US" sz="1700" dirty="0" err="1">
+                <a:solidFill>
+                  <a:srgbClr val="5F6368"/>
+                </a:solidFill>
+                <a:latin typeface="Noto Sans CJK JP" pitchFamily="34" charset="0"/>
+                <a:ea typeface="Noto Sans CJK JP" pitchFamily="34" charset="-122"/>
+                <a:cs typeface="Noto Sans CJK JP" pitchFamily="34" charset="-120"/>
+              </a:rPr>
+              <a:t>大切な指標。でも、それだけではない</a:t>
+            </a:r>
+            <a:r>
               <a:rPr lang="en-US" sz="1700" dirty="0">
                 <a:solidFill>
                   <a:srgbClr val="5F6368"/>
@@ -1368,7 +1312,7 @@
                 <a:ea typeface="Noto Sans CJK JP" pitchFamily="34" charset="-122"/>
                 <a:cs typeface="Noto Sans CJK JP" pitchFamily="34" charset="-120"/>
               </a:rPr>
-              <a:t>大切な指標。でも、それだけではない。</a:t>
+              <a:t>。</a:t>
             </a:r>
             <a:endParaRPr lang="en-US" sz="1700" dirty="0"/>
           </a:p>
@@ -1835,33 +1779,8 @@
           </a:ln>
         </p:spPr>
         <p:txBody>
-          <a:bodyPr/>
-          <a:lstStyle/>
-          <a:p>
-            <a:endParaRPr lang="ja-JP" altLang="en-US"/>
-          </a:p>
-        </p:txBody>
-      </p:sp>
-      <p:sp>
-        <p:nvSpPr>
-          <p:cNvPr id="21" name="Text 19"/>
-          <p:cNvSpPr/>
-          <p:nvPr/>
-        </p:nvSpPr>
-        <p:spPr>
-          <a:xfrm>
-            <a:off x="1325880" y="5424944"/>
-            <a:ext cx="9509760" cy="438912"/>
-          </a:xfrm>
-          <a:prstGeom prst="rect">
-            <a:avLst/>
-          </a:prstGeom>
-          <a:noFill/>
-          <a:ln/>
-        </p:spPr>
-        <p:txBody>
-          <a:bodyPr wrap="square" lIns="0" tIns="0" rIns="0" bIns="0" rtlCol="0" anchor="ctr">
-            <a:normAutofit fontScale="92500"/>
+          <a:bodyPr wrap="square" lIns="91440" tIns="45720" rIns="91440" bIns="45720" anchor="ctr">
+            <a:normAutofit/>
           </a:bodyPr>
           <a:lstStyle/>
           <a:p>
@@ -1877,7 +1796,53 @@
                 <a:ea typeface="Noto Sans CJK JP" pitchFamily="34" charset="-122"/>
                 <a:cs typeface="Noto Sans CJK JP" pitchFamily="34" charset="-120"/>
               </a:rPr>
-              <a:t>「AIだから当たる」ではなく、AIカメラを含む検査システム全体を理解する。</a:t>
+              <a:t>「</a:t>
+            </a:r>
+            <a:r>
+              <a:rPr lang="en-US" sz="2300" b="1" dirty="0" err="1">
+                <a:solidFill>
+                  <a:srgbClr val="1F4E79"/>
+                </a:solidFill>
+                <a:latin typeface="Noto Sans CJK JP" pitchFamily="34" charset="0"/>
+                <a:ea typeface="Noto Sans CJK JP" pitchFamily="34" charset="-122"/>
+                <a:cs typeface="Noto Sans CJK JP" pitchFamily="34" charset="-120"/>
+              </a:rPr>
+              <a:t>AIだから当たる」ではなく、AIカメラを含む</a:t>
+            </a:r>
+            <a:endParaRPr lang="en-US" sz="2300" b="1" dirty="0">
+              <a:solidFill>
+                <a:srgbClr val="1F4E79"/>
+              </a:solidFill>
+              <a:latin typeface="Noto Sans CJK JP" pitchFamily="34" charset="0"/>
+              <a:ea typeface="Noto Sans CJK JP" pitchFamily="34" charset="-122"/>
+              <a:cs typeface="Noto Sans CJK JP" pitchFamily="34" charset="-120"/>
+            </a:endParaRPr>
+          </a:p>
+          <a:p>
+            <a:pPr marL="0" indent="0" algn="ctr">
+              <a:buNone/>
+            </a:pPr>
+            <a:r>
+              <a:rPr lang="en-US" sz="2300" b="1" dirty="0" err="1">
+                <a:solidFill>
+                  <a:srgbClr val="1F4E79"/>
+                </a:solidFill>
+                <a:latin typeface="Noto Sans CJK JP" pitchFamily="34" charset="0"/>
+                <a:ea typeface="Noto Sans CJK JP" pitchFamily="34" charset="-122"/>
+                <a:cs typeface="Noto Sans CJK JP" pitchFamily="34" charset="-120"/>
+              </a:rPr>
+              <a:t>検査システム全体を理解する</a:t>
+            </a:r>
+            <a:r>
+              <a:rPr lang="en-US" sz="2300" b="1" dirty="0">
+                <a:solidFill>
+                  <a:srgbClr val="1F4E79"/>
+                </a:solidFill>
+                <a:latin typeface="Noto Sans CJK JP" pitchFamily="34" charset="0"/>
+                <a:ea typeface="Noto Sans CJK JP" pitchFamily="34" charset="-122"/>
+                <a:cs typeface="Noto Sans CJK JP" pitchFamily="34" charset="-120"/>
+              </a:rPr>
+              <a:t>。</a:t>
             </a:r>
             <a:endParaRPr lang="en-US" sz="2300" dirty="0"/>
           </a:p>
@@ -1903,7 +1868,7 @@
           </a:prstGeom>
           <a:extLst>
             <a:ext uri="{C572A759-6A51-4108-AA02-DFA0A04FC94B}">
-              <ma14:wrappingTextBoxFlag xmlns:ma14="http://schemas.microsoft.com/office/mac/drawingml/2011/main" xmlns="" val="0"/>
+              <ma14:wrappingTextBoxFlag xmlns="" xmlns:ma14="http://schemas.microsoft.com/office/mac/drawingml/2011/main" val="0"/>
             </a:ext>
           </a:extLst>
         </p:spPr>
@@ -2061,32 +2026,7 @@
           </a:ln>
         </p:spPr>
         <p:txBody>
-          <a:bodyPr/>
-          <a:lstStyle/>
-          <a:p>
-            <a:endParaRPr lang="ja-JP" altLang="en-US"/>
-          </a:p>
-        </p:txBody>
-      </p:sp>
-      <p:sp>
-        <p:nvSpPr>
-          <p:cNvPr id="5" name="Text 3"/>
-          <p:cNvSpPr/>
-          <p:nvPr/>
-        </p:nvSpPr>
-        <p:spPr>
-          <a:xfrm>
-            <a:off x="576072" y="2011680"/>
-            <a:ext cx="1271016" cy="868680"/>
-          </a:xfrm>
-          <a:prstGeom prst="rect">
-            <a:avLst/>
-          </a:prstGeom>
-          <a:noFill/>
-          <a:ln/>
-        </p:spPr>
-        <p:txBody>
-          <a:bodyPr wrap="square" lIns="508" tIns="508" rIns="508" bIns="508" rtlCol="0" anchor="ctr">
+          <a:bodyPr wrap="square" lIns="91440" tIns="45720" rIns="91440" bIns="45720" anchor="ctr">
             <a:normAutofit/>
           </a:bodyPr>
           <a:lstStyle/>
@@ -2095,7 +2035,7 @@
               <a:buNone/>
             </a:pPr>
             <a:r>
-              <a:rPr lang="en-US" sz="1600" b="1" dirty="0">
+              <a:rPr lang="en-US" sz="1600" b="1">
                 <a:solidFill>
                   <a:srgbClr val="202124"/>
                 </a:solidFill>
@@ -2105,14 +2045,14 @@
               </a:rPr>
               <a:t>IRセンサ</a:t>
             </a:r>
-            <a:endParaRPr lang="en-US" sz="1600" dirty="0"/>
+            <a:endParaRPr lang="en-US" sz="1600"/>
           </a:p>
           <a:p>
             <a:pPr marL="0" indent="0" algn="ctr">
               <a:buNone/>
             </a:pPr>
             <a:r>
-              <a:rPr lang="en-US" sz="1600" b="1" dirty="0">
+              <a:rPr lang="en-US" sz="1600" b="1">
                 <a:solidFill>
                   <a:srgbClr val="202124"/>
                 </a:solidFill>
@@ -2122,7 +2062,7 @@
               </a:rPr>
               <a:t>検査開始</a:t>
             </a:r>
-            <a:endParaRPr lang="en-US" sz="1600" dirty="0"/>
+            <a:endParaRPr lang="en-US" sz="1600"/>
           </a:p>
         </p:txBody>
       </p:sp>
@@ -2185,32 +2125,7 @@
           </a:ln>
         </p:spPr>
         <p:txBody>
-          <a:bodyPr/>
-          <a:lstStyle/>
-          <a:p>
-            <a:endParaRPr lang="ja-JP" altLang="en-US"/>
-          </a:p>
-        </p:txBody>
-      </p:sp>
-      <p:sp>
-        <p:nvSpPr>
-          <p:cNvPr id="8" name="Text 6"/>
-          <p:cNvSpPr/>
-          <p:nvPr/>
-        </p:nvSpPr>
-        <p:spPr>
-          <a:xfrm>
-            <a:off x="2404872" y="2011680"/>
-            <a:ext cx="1271016" cy="868680"/>
-          </a:xfrm>
-          <a:prstGeom prst="rect">
-            <a:avLst/>
-          </a:prstGeom>
-          <a:noFill/>
-          <a:ln/>
-        </p:spPr>
-        <p:txBody>
-          <a:bodyPr wrap="square" lIns="508" tIns="508" rIns="508" bIns="508" rtlCol="0" anchor="ctr">
+          <a:bodyPr wrap="square" lIns="91440" tIns="45720" rIns="91440" bIns="45720" anchor="ctr">
             <a:normAutofit/>
           </a:bodyPr>
           <a:lstStyle/>
@@ -2219,7 +2134,7 @@
               <a:buNone/>
             </a:pPr>
             <a:r>
-              <a:rPr lang="en-US" sz="1600" b="1" dirty="0">
+              <a:rPr lang="en-US" sz="1600" b="1">
                 <a:solidFill>
                   <a:srgbClr val="202124"/>
                 </a:solidFill>
@@ -2229,14 +2144,14 @@
               </a:rPr>
               <a:t>HUSKYLENS</a:t>
             </a:r>
-            <a:endParaRPr lang="en-US" sz="1600" dirty="0"/>
+            <a:endParaRPr lang="en-US" sz="1600"/>
           </a:p>
           <a:p>
             <a:pPr marL="0" indent="0" algn="ctr">
               <a:buNone/>
             </a:pPr>
             <a:r>
-              <a:rPr lang="en-US" sz="1600" b="1" dirty="0">
+              <a:rPr lang="en-US" sz="1600" b="1">
                 <a:solidFill>
                   <a:srgbClr val="202124"/>
                 </a:solidFill>
@@ -2246,7 +2161,7 @@
               </a:rPr>
               <a:t>推定ID</a:t>
             </a:r>
-            <a:endParaRPr lang="en-US" sz="1600" dirty="0"/>
+            <a:endParaRPr lang="en-US" sz="1600"/>
           </a:p>
         </p:txBody>
       </p:sp>
@@ -2309,32 +2224,7 @@
           </a:ln>
         </p:spPr>
         <p:txBody>
-          <a:bodyPr/>
-          <a:lstStyle/>
-          <a:p>
-            <a:endParaRPr lang="ja-JP" altLang="en-US"/>
-          </a:p>
-        </p:txBody>
-      </p:sp>
-      <p:sp>
-        <p:nvSpPr>
-          <p:cNvPr id="11" name="Text 9"/>
-          <p:cNvSpPr/>
-          <p:nvPr/>
-        </p:nvSpPr>
-        <p:spPr>
-          <a:xfrm>
-            <a:off x="4325112" y="2011680"/>
-            <a:ext cx="1271016" cy="868680"/>
-          </a:xfrm>
-          <a:prstGeom prst="rect">
-            <a:avLst/>
-          </a:prstGeom>
-          <a:noFill/>
-          <a:ln/>
-        </p:spPr>
-        <p:txBody>
-          <a:bodyPr wrap="square" lIns="508" tIns="508" rIns="508" bIns="508" rtlCol="0" anchor="ctr">
+          <a:bodyPr wrap="square" lIns="91440" tIns="45720" rIns="91440" bIns="45720" anchor="ctr">
             <a:normAutofit/>
           </a:bodyPr>
           <a:lstStyle/>
@@ -2343,7 +2233,7 @@
               <a:buNone/>
             </a:pPr>
             <a:r>
-              <a:rPr lang="en-US" sz="1600" b="1" dirty="0">
+              <a:rPr lang="en-US" sz="1600" b="1">
                 <a:solidFill>
                   <a:srgbClr val="202124"/>
                 </a:solidFill>
@@ -2353,14 +2243,14 @@
               </a:rPr>
               <a:t>M5</a:t>
             </a:r>
-            <a:endParaRPr lang="en-US" sz="1600" dirty="0"/>
+            <a:endParaRPr lang="en-US" sz="1600"/>
           </a:p>
           <a:p>
             <a:pPr marL="0" indent="0" algn="ctr">
               <a:buNone/>
             </a:pPr>
             <a:r>
-              <a:rPr lang="en-US" sz="1600" b="1" dirty="0">
+              <a:rPr lang="en-US" sz="1600" b="1">
                 <a:solidFill>
                   <a:srgbClr val="202124"/>
                 </a:solidFill>
@@ -2370,7 +2260,7 @@
               </a:rPr>
               <a:t>良否判定</a:t>
             </a:r>
-            <a:endParaRPr lang="en-US" sz="1600" dirty="0"/>
+            <a:endParaRPr lang="en-US" sz="1600"/>
           </a:p>
         </p:txBody>
       </p:sp>
@@ -2433,32 +2323,7 @@
           </a:ln>
         </p:spPr>
         <p:txBody>
-          <a:bodyPr/>
-          <a:lstStyle/>
-          <a:p>
-            <a:endParaRPr lang="ja-JP" altLang="en-US"/>
-          </a:p>
-        </p:txBody>
-      </p:sp>
-      <p:sp>
-        <p:nvSpPr>
-          <p:cNvPr id="14" name="Text 12"/>
-          <p:cNvSpPr/>
-          <p:nvPr/>
-        </p:nvSpPr>
-        <p:spPr>
-          <a:xfrm>
-            <a:off x="6245352" y="2011680"/>
-            <a:ext cx="1271016" cy="868680"/>
-          </a:xfrm>
-          <a:prstGeom prst="rect">
-            <a:avLst/>
-          </a:prstGeom>
-          <a:noFill/>
-          <a:ln/>
-        </p:spPr>
-        <p:txBody>
-          <a:bodyPr wrap="square" lIns="508" tIns="508" rIns="508" bIns="508" rtlCol="0" anchor="ctr">
+          <a:bodyPr wrap="square" lIns="91440" tIns="45720" rIns="91440" bIns="45720" anchor="ctr">
             <a:normAutofit/>
           </a:bodyPr>
           <a:lstStyle/>
@@ -2467,7 +2332,7 @@
               <a:buNone/>
             </a:pPr>
             <a:r>
-              <a:rPr lang="en-US" sz="1600" b="1" dirty="0">
+              <a:rPr lang="en-US" sz="1600" b="1">
                 <a:solidFill>
                   <a:srgbClr val="202124"/>
                 </a:solidFill>
@@ -2477,14 +2342,14 @@
               </a:rPr>
               <a:t>Relay</a:t>
             </a:r>
-            <a:endParaRPr lang="en-US" sz="1600" dirty="0"/>
+            <a:endParaRPr lang="en-US" sz="1600"/>
           </a:p>
           <a:p>
             <a:pPr marL="0" indent="0" algn="ctr">
               <a:buNone/>
             </a:pPr>
             <a:r>
-              <a:rPr lang="en-US" sz="1600" b="1" dirty="0">
+              <a:rPr lang="en-US" sz="1600" b="1">
                 <a:solidFill>
                   <a:srgbClr val="202124"/>
                 </a:solidFill>
@@ -2494,7 +2359,7 @@
               </a:rPr>
               <a:t>接点出力</a:t>
             </a:r>
-            <a:endParaRPr lang="en-US" sz="1600" dirty="0"/>
+            <a:endParaRPr lang="en-US" sz="1600"/>
           </a:p>
         </p:txBody>
       </p:sp>
@@ -2557,32 +2422,7 @@
           </a:ln>
         </p:spPr>
         <p:txBody>
-          <a:bodyPr/>
-          <a:lstStyle/>
-          <a:p>
-            <a:endParaRPr lang="ja-JP" altLang="en-US"/>
-          </a:p>
-        </p:txBody>
-      </p:sp>
-      <p:sp>
-        <p:nvSpPr>
-          <p:cNvPr id="17" name="Text 15"/>
-          <p:cNvSpPr/>
-          <p:nvPr/>
-        </p:nvSpPr>
-        <p:spPr>
-          <a:xfrm>
-            <a:off x="8165592" y="2011680"/>
-            <a:ext cx="1271016" cy="868680"/>
-          </a:xfrm>
-          <a:prstGeom prst="rect">
-            <a:avLst/>
-          </a:prstGeom>
-          <a:noFill/>
-          <a:ln/>
-        </p:spPr>
-        <p:txBody>
-          <a:bodyPr wrap="square" lIns="508" tIns="508" rIns="508" bIns="508" rtlCol="0" anchor="ctr">
+          <a:bodyPr wrap="square" lIns="91440" tIns="45720" rIns="91440" bIns="45720" anchor="ctr">
             <a:normAutofit/>
           </a:bodyPr>
           <a:lstStyle/>
@@ -2591,7 +2431,7 @@
               <a:buNone/>
             </a:pPr>
             <a:r>
-              <a:rPr lang="en-US" sz="1600" b="1" dirty="0">
+              <a:rPr lang="en-US" sz="1600" b="1">
                 <a:solidFill>
                   <a:srgbClr val="202124"/>
                 </a:solidFill>
@@ -2601,14 +2441,14 @@
               </a:rPr>
               <a:t>PLC</a:t>
             </a:r>
-            <a:endParaRPr lang="en-US" sz="1600" dirty="0"/>
+            <a:endParaRPr lang="en-US" sz="1600"/>
           </a:p>
           <a:p>
             <a:pPr marL="0" indent="0" algn="ctr">
               <a:buNone/>
             </a:pPr>
             <a:r>
-              <a:rPr lang="en-US" sz="1600" b="1" dirty="0">
+              <a:rPr lang="en-US" sz="1600" b="1">
                 <a:solidFill>
                   <a:srgbClr val="202124"/>
                 </a:solidFill>
@@ -2618,7 +2458,7 @@
               </a:rPr>
               <a:t>X00入力</a:t>
             </a:r>
-            <a:endParaRPr lang="en-US" sz="1600" dirty="0"/>
+            <a:endParaRPr lang="en-US" sz="1600"/>
           </a:p>
         </p:txBody>
       </p:sp>
@@ -2681,32 +2521,7 @@
           </a:ln>
         </p:spPr>
         <p:txBody>
-          <a:bodyPr/>
-          <a:lstStyle/>
-          <a:p>
-            <a:endParaRPr lang="ja-JP" altLang="en-US"/>
-          </a:p>
-        </p:txBody>
-      </p:sp>
-      <p:sp>
-        <p:nvSpPr>
-          <p:cNvPr id="20" name="Text 18"/>
-          <p:cNvSpPr/>
-          <p:nvPr/>
-        </p:nvSpPr>
-        <p:spPr>
-          <a:xfrm>
-            <a:off x="10085832" y="2011680"/>
-            <a:ext cx="1271016" cy="868680"/>
-          </a:xfrm>
-          <a:prstGeom prst="rect">
-            <a:avLst/>
-          </a:prstGeom>
-          <a:noFill/>
-          <a:ln/>
-        </p:spPr>
-        <p:txBody>
-          <a:bodyPr wrap="square" lIns="508" tIns="508" rIns="508" bIns="508" rtlCol="0" anchor="ctr">
+          <a:bodyPr wrap="square" lIns="91440" tIns="45720" rIns="91440" bIns="45720" anchor="ctr">
             <a:normAutofit/>
           </a:bodyPr>
           <a:lstStyle/>
@@ -2715,7 +2530,7 @@
               <a:buNone/>
             </a:pPr>
             <a:r>
-              <a:rPr lang="en-US" sz="1600" b="1" dirty="0">
+              <a:rPr lang="en-US" sz="1600" b="1">
                 <a:solidFill>
                   <a:srgbClr val="202124"/>
                 </a:solidFill>
@@ -2725,14 +2540,14 @@
               </a:rPr>
               <a:t>FA設備</a:t>
             </a:r>
-            <a:endParaRPr lang="en-US" sz="1600" dirty="0"/>
+            <a:endParaRPr lang="en-US" sz="1600"/>
           </a:p>
           <a:p>
             <a:pPr marL="0" indent="0" algn="ctr">
               <a:buNone/>
             </a:pPr>
             <a:r>
-              <a:rPr lang="en-US" sz="1600" b="1" dirty="0">
+              <a:rPr lang="en-US" sz="1600" b="1">
                 <a:solidFill>
                   <a:srgbClr val="202124"/>
                 </a:solidFill>
@@ -2742,7 +2557,7 @@
               </a:rPr>
               <a:t>設備動作</a:t>
             </a:r>
-            <a:endParaRPr lang="en-US" sz="1600" dirty="0"/>
+            <a:endParaRPr lang="en-US" sz="1600"/>
           </a:p>
         </p:txBody>
       </p:sp>
@@ -2773,71 +2588,7 @@
           </a:ln>
         </p:spPr>
         <p:txBody>
-          <a:bodyPr/>
-          <a:lstStyle/>
-          <a:p>
-            <a:endParaRPr lang="ja-JP" altLang="en-US"/>
-          </a:p>
-        </p:txBody>
-      </p:sp>
-      <p:sp>
-        <p:nvSpPr>
-          <p:cNvPr id="22" name="Text 20"/>
-          <p:cNvSpPr/>
-          <p:nvPr/>
-        </p:nvSpPr>
-        <p:spPr>
-          <a:xfrm>
-            <a:off x="758952" y="3483864"/>
-            <a:ext cx="2871216" cy="310896"/>
-          </a:xfrm>
-          <a:prstGeom prst="rect">
-            <a:avLst/>
-          </a:prstGeom>
-          <a:noFill/>
-          <a:ln/>
-        </p:spPr>
-        <p:txBody>
-          <a:bodyPr wrap="square" lIns="0" tIns="0" rIns="0" bIns="0" rtlCol="0" anchor="ctr"/>
-          <a:lstStyle/>
-          <a:p>
-            <a:pPr marL="0" indent="0">
-              <a:buNone/>
-            </a:pPr>
-            <a:r>
-              <a:rPr lang="en-US" sz="1800" b="1" dirty="0">
-                <a:solidFill>
-                  <a:srgbClr val="C55A11"/>
-                </a:solidFill>
-                <a:latin typeface="Noto Sans CJK JP" pitchFamily="34" charset="0"/>
-                <a:ea typeface="Noto Sans CJK JP" pitchFamily="34" charset="-122"/>
-                <a:cs typeface="Noto Sans CJK JP" pitchFamily="34" charset="-120"/>
-              </a:rPr>
-              <a:t>AIカメラの分類機能</a:t>
-            </a:r>
-            <a:endParaRPr lang="en-US" sz="1800" dirty="0"/>
-          </a:p>
-        </p:txBody>
-      </p:sp>
-      <p:sp>
-        <p:nvSpPr>
-          <p:cNvPr id="23" name="Text 21"/>
-          <p:cNvSpPr/>
-          <p:nvPr/>
-        </p:nvSpPr>
-        <p:spPr>
-          <a:xfrm>
-            <a:off x="758952" y="3867912"/>
-            <a:ext cx="2871216" cy="713232"/>
-          </a:xfrm>
-          <a:prstGeom prst="rect">
-            <a:avLst/>
-          </a:prstGeom>
-          <a:noFill/>
-          <a:ln/>
-        </p:spPr>
-        <p:txBody>
-          <a:bodyPr wrap="square" lIns="254" tIns="254" rIns="254" bIns="254" rtlCol="0" anchor="ctr">
+          <a:bodyPr wrap="square" lIns="91440" tIns="45720" rIns="91440" bIns="45720" anchor="ctr">
             <a:normAutofit/>
           </a:bodyPr>
           <a:lstStyle/>
@@ -2846,6 +2597,40 @@
               <a:buNone/>
             </a:pPr>
             <a:r>
+              <a:rPr lang="en-US" sz="1800" b="1" dirty="0" err="1">
+                <a:solidFill>
+                  <a:srgbClr val="C55A11"/>
+                </a:solidFill>
+                <a:latin typeface="Noto Sans CJK JP" pitchFamily="34" charset="0"/>
+                <a:ea typeface="Noto Sans CJK JP" pitchFamily="34" charset="-122"/>
+                <a:cs typeface="Noto Sans CJK JP" pitchFamily="34" charset="-120"/>
+              </a:rPr>
+              <a:t>AIカメラの分類機能</a:t>
+            </a:r>
+            <a:endParaRPr lang="en-US" sz="1800" dirty="0"/>
+          </a:p>
+          <a:p>
+            <a:pPr marL="0" indent="0">
+              <a:buNone/>
+            </a:pPr>
+            <a:r>
+              <a:rPr lang="en-US" sz="1500" dirty="0" err="1">
+                <a:solidFill>
+                  <a:srgbClr val="202124"/>
+                </a:solidFill>
+                <a:latin typeface="Noto Sans CJK JP" pitchFamily="34" charset="0"/>
+                <a:ea typeface="Noto Sans CJK JP" pitchFamily="34" charset="-122"/>
+                <a:cs typeface="Noto Sans CJK JP" pitchFamily="34" charset="-120"/>
+              </a:rPr>
+              <a:t>誤分類・未認識は起こりうる</a:t>
+            </a:r>
+            <a:endParaRPr lang="en-US" sz="1500" dirty="0"/>
+          </a:p>
+          <a:p>
+            <a:pPr marL="0" indent="0">
+              <a:buNone/>
+            </a:pPr>
+            <a:r>
               <a:rPr lang="en-US" sz="1500" dirty="0">
                 <a:solidFill>
                   <a:srgbClr val="202124"/>
@@ -2854,24 +2639,18 @@
                 <a:ea typeface="Noto Sans CJK JP" pitchFamily="34" charset="-122"/>
                 <a:cs typeface="Noto Sans CJK JP" pitchFamily="34" charset="-120"/>
               </a:rPr>
-              <a:t>誤分類・未認識は起こりうる</a:t>
-            </a:r>
-            <a:endParaRPr lang="en-US" sz="1500" dirty="0"/>
-          </a:p>
-          <a:p>
-            <a:pPr marL="0" indent="0">
-              <a:buNone/>
-            </a:pPr>
-            <a:r>
-              <a:rPr lang="en-US" sz="1500" dirty="0">
-                <a:solidFill>
-                  <a:srgbClr val="202124"/>
-                </a:solidFill>
-                <a:latin typeface="Noto Sans CJK JP" pitchFamily="34" charset="0"/>
-                <a:ea typeface="Noto Sans CJK JP" pitchFamily="34" charset="-122"/>
-                <a:cs typeface="Noto Sans CJK JP" pitchFamily="34" charset="-120"/>
-              </a:rPr>
-              <a:t>→ 学習状態やクラス間の違いを見る</a:t>
+              <a:t>→ </a:t>
+            </a:r>
+            <a:r>
+              <a:rPr lang="en-US" sz="1500" dirty="0" err="1">
+                <a:solidFill>
+                  <a:srgbClr val="202124"/>
+                </a:solidFill>
+                <a:latin typeface="Noto Sans CJK JP" pitchFamily="34" charset="0"/>
+                <a:ea typeface="Noto Sans CJK JP" pitchFamily="34" charset="-122"/>
+                <a:cs typeface="Noto Sans CJK JP" pitchFamily="34" charset="-120"/>
+              </a:rPr>
+              <a:t>学習状態やクラス間の違いを見る</a:t>
             </a:r>
             <a:endParaRPr lang="en-US" sz="1500" dirty="0"/>
           </a:p>
@@ -2904,71 +2683,7 @@
           </a:ln>
         </p:spPr>
         <p:txBody>
-          <a:bodyPr/>
-          <a:lstStyle/>
-          <a:p>
-            <a:endParaRPr lang="ja-JP" altLang="en-US"/>
-          </a:p>
-        </p:txBody>
-      </p:sp>
-      <p:sp>
-        <p:nvSpPr>
-          <p:cNvPr id="25" name="Text 23"/>
-          <p:cNvSpPr/>
-          <p:nvPr/>
-        </p:nvSpPr>
-        <p:spPr>
-          <a:xfrm>
-            <a:off x="4142232" y="3483864"/>
-            <a:ext cx="3328416" cy="310896"/>
-          </a:xfrm>
-          <a:prstGeom prst="rect">
-            <a:avLst/>
-          </a:prstGeom>
-          <a:noFill/>
-          <a:ln/>
-        </p:spPr>
-        <p:txBody>
-          <a:bodyPr wrap="square" lIns="0" tIns="0" rIns="0" bIns="0" rtlCol="0" anchor="ctr"/>
-          <a:lstStyle/>
-          <a:p>
-            <a:pPr marL="0" indent="0">
-              <a:buNone/>
-            </a:pPr>
-            <a:r>
-              <a:rPr lang="en-US" sz="1800" b="1" dirty="0">
-                <a:solidFill>
-                  <a:srgbClr val="2F75B5"/>
-                </a:solidFill>
-                <a:latin typeface="Noto Sans CJK JP" pitchFamily="34" charset="0"/>
-                <a:ea typeface="Noto Sans CJK JP" pitchFamily="34" charset="-122"/>
-                <a:cs typeface="Noto Sans CJK JP" pitchFamily="34" charset="-120"/>
-              </a:rPr>
-              <a:t>撮像環境・タイミング</a:t>
-            </a:r>
-            <a:endParaRPr lang="en-US" sz="1800" dirty="0"/>
-          </a:p>
-        </p:txBody>
-      </p:sp>
-      <p:sp>
-        <p:nvSpPr>
-          <p:cNvPr id="26" name="Text 24"/>
-          <p:cNvSpPr/>
-          <p:nvPr/>
-        </p:nvSpPr>
-        <p:spPr>
-          <a:xfrm>
-            <a:off x="4142232" y="3867912"/>
-            <a:ext cx="3447288" cy="713232"/>
-          </a:xfrm>
-          <a:prstGeom prst="rect">
-            <a:avLst/>
-          </a:prstGeom>
-          <a:noFill/>
-          <a:ln/>
-        </p:spPr>
-        <p:txBody>
-          <a:bodyPr wrap="square" lIns="254" tIns="254" rIns="254" bIns="254" rtlCol="0" anchor="ctr">
+          <a:bodyPr wrap="square" lIns="91440" tIns="45720" rIns="91440" bIns="45720" anchor="ctr">
             <a:normAutofit/>
           </a:bodyPr>
           <a:lstStyle/>
@@ -2977,7 +2692,24 @@
               <a:buNone/>
             </a:pPr>
             <a:r>
-              <a:rPr lang="en-US" sz="1500" dirty="0">
+              <a:rPr lang="en-US" sz="1800" b="1" dirty="0" err="1">
+                <a:solidFill>
+                  <a:srgbClr val="2F75B5"/>
+                </a:solidFill>
+                <a:latin typeface="Noto Sans CJK JP" pitchFamily="34" charset="0"/>
+                <a:ea typeface="Noto Sans CJK JP" pitchFamily="34" charset="-122"/>
+                <a:cs typeface="Noto Sans CJK JP" pitchFamily="34" charset="-120"/>
+              </a:rPr>
+              <a:t>撮像環境・タイミング</a:t>
+            </a:r>
+            <a:endParaRPr lang="en-US" sz="1800" dirty="0"/>
+          </a:p>
+          <a:p>
+            <a:pPr marL="0" indent="0">
+              <a:buNone/>
+            </a:pPr>
+            <a:r>
+              <a:rPr lang="en-US" sz="1500" dirty="0" err="1">
                 <a:solidFill>
                   <a:srgbClr val="202124"/>
                 </a:solidFill>
@@ -2994,7 +2726,7 @@
               <a:buNone/>
             </a:pPr>
             <a:r>
-              <a:rPr lang="en-US" sz="1500" dirty="0">
+              <a:rPr lang="en-US" sz="1500" dirty="0" err="1">
                 <a:solidFill>
                   <a:srgbClr val="202124"/>
                 </a:solidFill>
@@ -3035,71 +2767,7 @@
           </a:ln>
         </p:spPr>
         <p:txBody>
-          <a:bodyPr/>
-          <a:lstStyle/>
-          <a:p>
-            <a:endParaRPr lang="ja-JP" altLang="en-US"/>
-          </a:p>
-        </p:txBody>
-      </p:sp>
-      <p:sp>
-        <p:nvSpPr>
-          <p:cNvPr id="28" name="Text 26"/>
-          <p:cNvSpPr/>
-          <p:nvPr/>
-        </p:nvSpPr>
-        <p:spPr>
-          <a:xfrm>
-            <a:off x="7982712" y="3483864"/>
-            <a:ext cx="3328416" cy="310896"/>
-          </a:xfrm>
-          <a:prstGeom prst="rect">
-            <a:avLst/>
-          </a:prstGeom>
-          <a:noFill/>
-          <a:ln/>
-        </p:spPr>
-        <p:txBody>
-          <a:bodyPr wrap="square" lIns="0" tIns="0" rIns="0" bIns="0" rtlCol="0" anchor="ctr"/>
-          <a:lstStyle/>
-          <a:p>
-            <a:pPr marL="0" indent="0">
-              <a:buNone/>
-            </a:pPr>
-            <a:r>
-              <a:rPr lang="en-US" sz="1800" b="1" dirty="0">
-                <a:solidFill>
-                  <a:srgbClr val="2E7D32"/>
-                </a:solidFill>
-                <a:latin typeface="Noto Sans CJK JP" pitchFamily="34" charset="0"/>
-                <a:ea typeface="Noto Sans CJK JP" pitchFamily="34" charset="-122"/>
-                <a:cs typeface="Noto Sans CJK JP" pitchFamily="34" charset="-120"/>
-              </a:rPr>
-              <a:t>FAとの連携</a:t>
-            </a:r>
-            <a:endParaRPr lang="en-US" sz="1800" dirty="0"/>
-          </a:p>
-        </p:txBody>
-      </p:sp>
-      <p:sp>
-        <p:nvSpPr>
-          <p:cNvPr id="29" name="Text 27"/>
-          <p:cNvSpPr/>
-          <p:nvPr/>
-        </p:nvSpPr>
-        <p:spPr>
-          <a:xfrm>
-            <a:off x="7982712" y="3867912"/>
-            <a:ext cx="3328416" cy="713232"/>
-          </a:xfrm>
-          <a:prstGeom prst="rect">
-            <a:avLst/>
-          </a:prstGeom>
-          <a:noFill/>
-          <a:ln/>
-        </p:spPr>
-        <p:txBody>
-          <a:bodyPr wrap="square" lIns="254" tIns="254" rIns="254" bIns="254" rtlCol="0" anchor="ctr">
+          <a:bodyPr wrap="square" lIns="91440" tIns="45720" rIns="91440" bIns="45720" anchor="ctr">
             <a:normAutofit/>
           </a:bodyPr>
           <a:lstStyle/>
@@ -3108,6 +2776,23 @@
               <a:buNone/>
             </a:pPr>
             <a:r>
+              <a:rPr lang="en-US" sz="1800" b="1" dirty="0" err="1">
+                <a:solidFill>
+                  <a:srgbClr val="2E7D32"/>
+                </a:solidFill>
+                <a:latin typeface="Noto Sans CJK JP" pitchFamily="34" charset="0"/>
+                <a:ea typeface="Noto Sans CJK JP" pitchFamily="34" charset="-122"/>
+                <a:cs typeface="Noto Sans CJK JP" pitchFamily="34" charset="-120"/>
+              </a:rPr>
+              <a:t>FAとの連携</a:t>
+            </a:r>
+            <a:endParaRPr lang="en-US" sz="1800" dirty="0"/>
+          </a:p>
+          <a:p>
+            <a:pPr marL="0" indent="0">
+              <a:buNone/>
+            </a:pPr>
+            <a:r>
               <a:rPr lang="en-US" sz="1500" dirty="0">
                 <a:solidFill>
                   <a:srgbClr val="202124"/>
@@ -3116,7 +2801,18 @@
                 <a:ea typeface="Noto Sans CJK JP" pitchFamily="34" charset="-122"/>
                 <a:cs typeface="Noto Sans CJK JP" pitchFamily="34" charset="-120"/>
               </a:rPr>
-              <a:t>M5 → Relay → PLC入力</a:t>
+              <a:t>M5 → Relay → </a:t>
+            </a:r>
+            <a:r>
+              <a:rPr lang="en-US" sz="1500" dirty="0" err="1">
+                <a:solidFill>
+                  <a:srgbClr val="202124"/>
+                </a:solidFill>
+                <a:latin typeface="Noto Sans CJK JP" pitchFamily="34" charset="0"/>
+                <a:ea typeface="Noto Sans CJK JP" pitchFamily="34" charset="-122"/>
+                <a:cs typeface="Noto Sans CJK JP" pitchFamily="34" charset="-120"/>
+              </a:rPr>
+              <a:t>PLC入力</a:t>
             </a:r>
             <a:endParaRPr lang="en-US" sz="1500" dirty="0"/>
           </a:p>
@@ -3166,33 +2862,8 @@
           </a:ln>
         </p:spPr>
         <p:txBody>
-          <a:bodyPr/>
-          <a:lstStyle/>
-          <a:p>
-            <a:endParaRPr lang="ja-JP" altLang="en-US"/>
-          </a:p>
-        </p:txBody>
-      </p:sp>
-      <p:sp>
-        <p:nvSpPr>
-          <p:cNvPr id="31" name="Text 29"/>
-          <p:cNvSpPr/>
-          <p:nvPr/>
-        </p:nvSpPr>
-        <p:spPr>
-          <a:xfrm>
-            <a:off x="1143000" y="5231219"/>
-            <a:ext cx="9875520" cy="465493"/>
-          </a:xfrm>
-          <a:prstGeom prst="rect">
-            <a:avLst/>
-          </a:prstGeom>
-          <a:noFill/>
-          <a:ln/>
-        </p:spPr>
-        <p:txBody>
-          <a:bodyPr wrap="square" lIns="0" tIns="0" rIns="0" bIns="0" rtlCol="0" anchor="ctr">
-            <a:normAutofit fontScale="92500" lnSpcReduction="20000"/>
+          <a:bodyPr wrap="square" lIns="91440" tIns="45720" rIns="91440" bIns="45720" anchor="ctr">
+            <a:normAutofit/>
           </a:bodyPr>
           <a:lstStyle/>
           <a:p>
@@ -3200,6 +2871,17 @@
               <a:buNone/>
             </a:pPr>
             <a:r>
+              <a:rPr lang="en-US" sz="1900" b="1" dirty="0" err="1">
+                <a:solidFill>
+                  <a:srgbClr val="202124"/>
+                </a:solidFill>
+                <a:latin typeface="Noto Sans CJK JP" pitchFamily="34" charset="0"/>
+                <a:ea typeface="Noto Sans CJK JP" pitchFamily="34" charset="-122"/>
+                <a:cs typeface="Noto Sans CJK JP" pitchFamily="34" charset="-120"/>
+              </a:rPr>
+              <a:t>一連の動作が不安定なら</a:t>
+            </a:r>
+            <a:r>
               <a:rPr lang="en-US" sz="1900" b="1" dirty="0">
                 <a:solidFill>
                   <a:srgbClr val="202124"/>
@@ -3208,7 +2890,7 @@
                 <a:ea typeface="Noto Sans CJK JP" pitchFamily="34" charset="-122"/>
                 <a:cs typeface="Noto Sans CJK JP" pitchFamily="34" charset="-120"/>
               </a:rPr>
-              <a:t>一連の動作が不安定なら、「</a:t>
+              <a:t>、「</a:t>
             </a:r>
             <a:r>
               <a:rPr lang="en-US" sz="1900" b="1" dirty="0" err="1">
@@ -3257,7 +2939,73 @@
                 <a:ea typeface="Noto Sans CJK JP" pitchFamily="34" charset="-122"/>
                 <a:cs typeface="Noto Sans CJK JP" pitchFamily="34" charset="-120"/>
               </a:rPr>
-              <a:t> → 推定 → 判断 → 出力を順に確認する。</a:t>
+              <a:t> → </a:t>
+            </a:r>
+            <a:r>
+              <a:rPr lang="en-US" sz="1900" b="1" dirty="0" err="1">
+                <a:solidFill>
+                  <a:srgbClr val="202124"/>
+                </a:solidFill>
+                <a:latin typeface="Noto Sans CJK JP" pitchFamily="34" charset="0"/>
+                <a:ea typeface="Noto Sans CJK JP" pitchFamily="34" charset="-122"/>
+                <a:cs typeface="Noto Sans CJK JP" pitchFamily="34" charset="-120"/>
+              </a:rPr>
+              <a:t>推定</a:t>
+            </a:r>
+            <a:r>
+              <a:rPr lang="en-US" sz="1900" b="1" dirty="0">
+                <a:solidFill>
+                  <a:srgbClr val="202124"/>
+                </a:solidFill>
+                <a:latin typeface="Noto Sans CJK JP" pitchFamily="34" charset="0"/>
+                <a:ea typeface="Noto Sans CJK JP" pitchFamily="34" charset="-122"/>
+                <a:cs typeface="Noto Sans CJK JP" pitchFamily="34" charset="-120"/>
+              </a:rPr>
+              <a:t> → </a:t>
+            </a:r>
+            <a:r>
+              <a:rPr lang="en-US" sz="1900" b="1" dirty="0" err="1">
+                <a:solidFill>
+                  <a:srgbClr val="202124"/>
+                </a:solidFill>
+                <a:latin typeface="Noto Sans CJK JP" pitchFamily="34" charset="0"/>
+                <a:ea typeface="Noto Sans CJK JP" pitchFamily="34" charset="-122"/>
+                <a:cs typeface="Noto Sans CJK JP" pitchFamily="34" charset="-120"/>
+              </a:rPr>
+              <a:t>判断</a:t>
+            </a:r>
+            <a:r>
+              <a:rPr lang="en-US" sz="1900" b="1" dirty="0">
+                <a:solidFill>
+                  <a:srgbClr val="202124"/>
+                </a:solidFill>
+                <a:latin typeface="Noto Sans CJK JP" pitchFamily="34" charset="0"/>
+                <a:ea typeface="Noto Sans CJK JP" pitchFamily="34" charset="-122"/>
+                <a:cs typeface="Noto Sans CJK JP" pitchFamily="34" charset="-120"/>
+              </a:rPr>
+              <a:t> → </a:t>
+            </a:r>
+            <a:r>
+              <a:rPr lang="en-US" sz="1900" b="1" dirty="0" err="1">
+                <a:solidFill>
+                  <a:srgbClr val="202124"/>
+                </a:solidFill>
+                <a:latin typeface="Noto Sans CJK JP" pitchFamily="34" charset="0"/>
+                <a:ea typeface="Noto Sans CJK JP" pitchFamily="34" charset="-122"/>
+                <a:cs typeface="Noto Sans CJK JP" pitchFamily="34" charset="-120"/>
+              </a:rPr>
+              <a:t>出力を順に確認する</a:t>
+            </a:r>
+            <a:r>
+              <a:rPr lang="en-US" sz="1900" b="1" dirty="0">
+                <a:solidFill>
+                  <a:srgbClr val="202124"/>
+                </a:solidFill>
+                <a:latin typeface="Noto Sans CJK JP" pitchFamily="34" charset="0"/>
+                <a:ea typeface="Noto Sans CJK JP" pitchFamily="34" charset="-122"/>
+                <a:cs typeface="Noto Sans CJK JP" pitchFamily="34" charset="-120"/>
+              </a:rPr>
+              <a:t>。</a:t>
             </a:r>
             <a:endParaRPr lang="en-US" sz="1900" dirty="0"/>
           </a:p>
@@ -3283,7 +3031,7 @@
           </a:prstGeom>
           <a:extLst>
             <a:ext uri="{C572A759-6A51-4108-AA02-DFA0A04FC94B}">
-              <ma14:wrappingTextBoxFlag xmlns:ma14="http://schemas.microsoft.com/office/mac/drawingml/2011/main" xmlns="" val="0"/>
+              <ma14:wrappingTextBoxFlag xmlns="" xmlns:ma14="http://schemas.microsoft.com/office/mac/drawingml/2011/main" val="0"/>
             </a:ext>
           </a:extLst>
         </p:spPr>
@@ -3336,6 +3084,45 @@
           <a:chExt cx="0" cy="0"/>
         </a:xfrm>
       </p:grpSpPr>
+      <p:cxnSp>
+        <p:nvCxnSpPr>
+          <p:cNvPr id="45" name="直線コネクタ 44">
+            <a:extLst>
+              <a:ext uri="{FF2B5EF4-FFF2-40B4-BE49-F238E27FC236}">
+                <a16:creationId xmlns:a16="http://schemas.microsoft.com/office/drawing/2014/main" id="{F7575BF9-88A1-F0E7-A598-ED715A056ED8}"/>
+              </a:ext>
+            </a:extLst>
+          </p:cNvPr>
+          <p:cNvCxnSpPr>
+            <a:cxnSpLocks/>
+            <a:endCxn id="5" idx="0"/>
+          </p:cNvCxnSpPr>
+          <p:nvPr/>
+        </p:nvCxnSpPr>
+        <p:spPr>
+          <a:xfrm>
+            <a:off x="6096000" y="2133600"/>
+            <a:ext cx="38100" cy="3886200"/>
+          </a:xfrm>
+          <a:prstGeom prst="line">
+            <a:avLst/>
+          </a:prstGeom>
+        </p:spPr>
+        <p:style>
+          <a:lnRef idx="1">
+            <a:schemeClr val="accent1"/>
+          </a:lnRef>
+          <a:fillRef idx="0">
+            <a:schemeClr val="accent1"/>
+          </a:fillRef>
+          <a:effectRef idx="0">
+            <a:schemeClr val="accent1"/>
+          </a:effectRef>
+          <a:fontRef idx="minor">
+            <a:schemeClr val="tx1"/>
+          </a:fontRef>
+        </p:style>
+      </p:cxnSp>
       <p:sp>
         <p:nvSpPr>
           <p:cNvPr id="2" name="Text 0"/>
@@ -3361,15 +3148,26 @@
               <a:buNone/>
             </a:pPr>
             <a:r>
-              <a:rPr lang="en-US" sz="2700" b="1" dirty="0">
-                <a:solidFill>
-                  <a:srgbClr val="202124"/>
-                </a:solidFill>
-                <a:latin typeface="Noto Sans CJK JP" pitchFamily="34" charset="0"/>
-                <a:ea typeface="Noto Sans CJK JP" pitchFamily="34" charset="-122"/>
-                <a:cs typeface="Noto Sans CJK JP" pitchFamily="34" charset="-120"/>
-              </a:rPr>
-              <a:t>用語を分けて考える</a:t>
+              <a:rPr lang="ja-JP" altLang="en-US" sz="2700" b="1" dirty="0">
+                <a:solidFill>
+                  <a:srgbClr val="202124"/>
+                </a:solidFill>
+                <a:latin typeface="Noto Sans CJK JP" pitchFamily="34" charset="0"/>
+                <a:ea typeface="Noto Sans CJK JP" pitchFamily="34" charset="-122"/>
+                <a:cs typeface="Noto Sans CJK JP" pitchFamily="34" charset="-120"/>
+              </a:rPr>
+              <a:t>⚠注意！</a:t>
+            </a:r>
+            <a:r>
+              <a:rPr lang="en-US" sz="2700" b="1" dirty="0" err="1">
+                <a:solidFill>
+                  <a:srgbClr val="202124"/>
+                </a:solidFill>
+                <a:latin typeface="Noto Sans CJK JP" pitchFamily="34" charset="0"/>
+                <a:ea typeface="Noto Sans CJK JP" pitchFamily="34" charset="-122"/>
+                <a:cs typeface="Noto Sans CJK JP" pitchFamily="34" charset="-120"/>
+              </a:rPr>
+              <a:t>用語</a:t>
             </a:r>
             <a:endParaRPr lang="en-US" sz="2700" dirty="0"/>
           </a:p>
@@ -3384,7 +3182,7 @@
         <p:spPr>
           <a:xfrm>
             <a:off x="612648" y="987552"/>
-            <a:ext cx="10789920" cy="292608"/>
+            <a:ext cx="10789920" cy="1146048"/>
           </a:xfrm>
           <a:prstGeom prst="rect">
             <a:avLst/>
@@ -3393,14 +3191,17 @@
           <a:ln/>
         </p:spPr>
         <p:txBody>
-          <a:bodyPr wrap="square" lIns="0" tIns="0" rIns="0" bIns="0" rtlCol="0" anchor="ctr"/>
+          <a:bodyPr wrap="square" lIns="0" tIns="0" rIns="0" bIns="0" rtlCol="0" anchor="t"/>
           <a:lstStyle/>
           <a:p>
             <a:pPr marL="0" indent="0">
-              <a:buNone/>
-            </a:pPr>
-            <a:r>
-              <a:rPr lang="en-US" sz="1300" dirty="0">
+              <a:lnSpc>
+                <a:spcPct val="130000"/>
+              </a:lnSpc>
+              <a:buNone/>
+            </a:pPr>
+            <a:r>
+              <a:rPr lang="en-US" sz="1400" dirty="0">
                 <a:solidFill>
                   <a:srgbClr val="5F6368"/>
                 </a:solidFill>
@@ -3408,9 +3209,84 @@
                 <a:ea typeface="Noto Sans CJK JP" pitchFamily="34" charset="-122"/>
                 <a:cs typeface="Noto Sans CJK JP" pitchFamily="34" charset="-120"/>
               </a:rPr>
-              <a:t>「IDが合ったか」と「良品・不良品の判定が合ったか」は別です。</a:t>
-            </a:r>
-            <a:endParaRPr lang="en-US" sz="1300" dirty="0"/>
+              <a:t>「</a:t>
+            </a:r>
+            <a:r>
+              <a:rPr lang="en-US" sz="1400" dirty="0" err="1">
+                <a:solidFill>
+                  <a:srgbClr val="5F6368"/>
+                </a:solidFill>
+                <a:latin typeface="Noto Sans CJK JP" pitchFamily="34" charset="0"/>
+                <a:ea typeface="Noto Sans CJK JP" pitchFamily="34" charset="-122"/>
+                <a:cs typeface="Noto Sans CJK JP" pitchFamily="34" charset="-120"/>
+              </a:rPr>
+              <a:t>IDが合ったか」と「良品・不良品の判定が合ったか」は別です</a:t>
+            </a:r>
+            <a:r>
+              <a:rPr lang="en-US" sz="1400" dirty="0">
+                <a:solidFill>
+                  <a:srgbClr val="5F6368"/>
+                </a:solidFill>
+                <a:latin typeface="Noto Sans CJK JP" pitchFamily="34" charset="0"/>
+                <a:ea typeface="Noto Sans CJK JP" pitchFamily="34" charset="-122"/>
+                <a:cs typeface="Noto Sans CJK JP" pitchFamily="34" charset="-120"/>
+              </a:rPr>
+              <a:t>。</a:t>
+            </a:r>
+          </a:p>
+          <a:p>
+            <a:pPr marL="0" indent="0">
+              <a:lnSpc>
+                <a:spcPct val="130000"/>
+              </a:lnSpc>
+              <a:buNone/>
+            </a:pPr>
+            <a:r>
+              <a:rPr lang="en-US" altLang="ja-JP" sz="1400" b="1" u="sng" dirty="0">
+                <a:solidFill>
+                  <a:srgbClr val="FF0000"/>
+                </a:solidFill>
+                <a:latin typeface="Noto Sans CJK JP" pitchFamily="34" charset="0"/>
+                <a:ea typeface="Noto Sans CJK JP" pitchFamily="34" charset="-122"/>
+              </a:rPr>
+              <a:t>ID </a:t>
+            </a:r>
+            <a:r>
+              <a:rPr lang="ja-JP" altLang="en-US" sz="1400" b="1" u="sng" dirty="0">
+                <a:solidFill>
+                  <a:srgbClr val="FF0000"/>
+                </a:solidFill>
+                <a:latin typeface="Noto Sans CJK JP" pitchFamily="34" charset="0"/>
+                <a:ea typeface="Noto Sans CJK JP" pitchFamily="34" charset="-122"/>
+              </a:rPr>
+              <a:t>が違っても、良品／不良品判定が一致することがあります。</a:t>
+            </a:r>
+            <a:endParaRPr lang="en-US" altLang="ja-JP" sz="1400" b="1" u="sng" dirty="0">
+              <a:solidFill>
+                <a:srgbClr val="FF0000"/>
+              </a:solidFill>
+              <a:latin typeface="Noto Sans CJK JP" pitchFamily="34" charset="0"/>
+              <a:ea typeface="Noto Sans CJK JP" pitchFamily="34" charset="-122"/>
+            </a:endParaRPr>
+          </a:p>
+          <a:p>
+            <a:pPr marL="0" indent="0">
+              <a:lnSpc>
+                <a:spcPct val="130000"/>
+              </a:lnSpc>
+              <a:buNone/>
+            </a:pPr>
+            <a:r>
+              <a:rPr lang="ja-JP" altLang="en-US" sz="1400" dirty="0">
+                <a:solidFill>
+                  <a:srgbClr val="5F6368"/>
+                </a:solidFill>
+                <a:latin typeface="Noto Sans CJK JP" pitchFamily="34" charset="0"/>
+                <a:ea typeface="Noto Sans CJK JP" pitchFamily="34" charset="-122"/>
+              </a:rPr>
+              <a:t>記録時、これを混同しないようにしましょう。</a:t>
+            </a:r>
+            <a:endParaRPr lang="en-US" sz="1400" dirty="0"/>
           </a:p>
         </p:txBody>
       </p:sp>
@@ -3422,8 +3298,8 @@
         </p:nvSpPr>
         <p:spPr>
           <a:xfrm>
-            <a:off x="731520" y="1417320"/>
-            <a:ext cx="2103120" cy="320040"/>
+            <a:off x="731520" y="1756410"/>
+            <a:ext cx="10857738" cy="320040"/>
           </a:xfrm>
           <a:prstGeom prst="rect">
             <a:avLst/>
@@ -3439,7 +3315,7 @@
               <a:buNone/>
             </a:pPr>
             <a:r>
-              <a:rPr lang="en-US" sz="1900" b="1" dirty="0">
+              <a:rPr lang="en-US" sz="1900" b="1" dirty="0" err="1">
                 <a:solidFill>
                   <a:srgbClr val="1F4E79"/>
                 </a:solidFill>
@@ -3447,7 +3323,7 @@
                 <a:ea typeface="Noto Sans CJK JP" pitchFamily="34" charset="-122"/>
                 <a:cs typeface="Noto Sans CJK JP" pitchFamily="34" charset="-120"/>
               </a:rPr>
-              <a:t>実物側</a:t>
+              <a:t>実物</a:t>
             </a:r>
             <a:endParaRPr lang="en-US" sz="1900" dirty="0"/>
           </a:p>
@@ -3461,8 +3337,8 @@
         </p:nvSpPr>
         <p:spPr>
           <a:xfrm>
-            <a:off x="5669280" y="1417320"/>
-            <a:ext cx="2560320" cy="320040"/>
+            <a:off x="457200" y="6019800"/>
+            <a:ext cx="11353800" cy="320040"/>
           </a:xfrm>
           <a:prstGeom prst="rect">
             <a:avLst/>
@@ -3478,7 +3354,7 @@
               <a:buNone/>
             </a:pPr>
             <a:r>
-              <a:rPr lang="en-US" sz="1900" b="1" dirty="0">
+              <a:rPr lang="en-US" sz="1900" b="1" dirty="0" err="1">
                 <a:solidFill>
                   <a:srgbClr val="1F4E79"/>
                 </a:solidFill>
@@ -3486,7 +3362,7 @@
                 <a:ea typeface="Noto Sans CJK JP" pitchFamily="34" charset="-122"/>
                 <a:cs typeface="Noto Sans CJK JP" pitchFamily="34" charset="-120"/>
               </a:rPr>
-              <a:t>システム側</a:t>
+              <a:t>システム</a:t>
             </a:r>
             <a:endParaRPr lang="en-US" sz="1900" dirty="0"/>
           </a:p>
@@ -3500,7 +3376,7 @@
         </p:nvSpPr>
         <p:spPr>
           <a:xfrm>
-            <a:off x="731520" y="1874520"/>
+            <a:off x="2171700" y="2185416"/>
             <a:ext cx="2057400" cy="658368"/>
           </a:xfrm>
           <a:prstGeom prst="roundRect">
@@ -3519,32 +3395,7 @@
           </a:ln>
         </p:spPr>
         <p:txBody>
-          <a:bodyPr/>
-          <a:lstStyle/>
-          <a:p>
-            <a:endParaRPr lang="ja-JP" altLang="en-US"/>
-          </a:p>
-        </p:txBody>
-      </p:sp>
-      <p:sp>
-        <p:nvSpPr>
-          <p:cNvPr id="7" name="Text 5"/>
-          <p:cNvSpPr/>
-          <p:nvPr/>
-        </p:nvSpPr>
-        <p:spPr>
-          <a:xfrm>
-            <a:off x="804672" y="1920240"/>
-            <a:ext cx="1911096" cy="566928"/>
-          </a:xfrm>
-          <a:prstGeom prst="rect">
-            <a:avLst/>
-          </a:prstGeom>
-          <a:noFill/>
-          <a:ln/>
-        </p:spPr>
-        <p:txBody>
-          <a:bodyPr wrap="square" lIns="508" tIns="508" rIns="508" bIns="508" rtlCol="0" anchor="ctr">
+          <a:bodyPr wrap="square" lIns="91440" tIns="45720" rIns="91440" bIns="45720" anchor="ctr">
             <a:normAutofit/>
           </a:bodyPr>
           <a:lstStyle/>
@@ -3553,7 +3404,7 @@
               <a:buNone/>
             </a:pPr>
             <a:r>
-              <a:rPr lang="en-US" sz="2000" b="1" dirty="0">
+              <a:rPr lang="en-US" sz="2000" b="1">
                 <a:solidFill>
                   <a:srgbClr val="202124"/>
                 </a:solidFill>
@@ -3563,39 +3414,7 @@
               </a:rPr>
               <a:t>正解ID</a:t>
             </a:r>
-            <a:endParaRPr lang="en-US" sz="2000" dirty="0"/>
-          </a:p>
-        </p:txBody>
-      </p:sp>
-      <p:sp>
-        <p:nvSpPr>
-          <p:cNvPr id="8" name="Shape 6"/>
-          <p:cNvSpPr/>
-          <p:nvPr/>
-        </p:nvSpPr>
-        <p:spPr>
-          <a:xfrm>
-            <a:off x="2852928" y="2203704"/>
-            <a:ext cx="941832" cy="0"/>
-          </a:xfrm>
-          <a:prstGeom prst="line">
-            <a:avLst/>
-          </a:prstGeom>
-          <a:noFill/>
-          <a:ln w="25400">
-            <a:solidFill>
-              <a:srgbClr val="5F6368"/>
-            </a:solidFill>
-            <a:prstDash val="solid"/>
-            <a:headEnd type="none"/>
-            <a:tailEnd type="triangle"/>
-          </a:ln>
-        </p:spPr>
-        <p:txBody>
-          <a:bodyPr/>
-          <a:lstStyle/>
-          <a:p>
-            <a:endParaRPr lang="ja-JP" altLang="en-US"/>
+            <a:endParaRPr lang="en-US" sz="2000"/>
           </a:p>
         </p:txBody>
       </p:sp>
@@ -3607,7 +3426,7 @@
         </p:nvSpPr>
         <p:spPr>
           <a:xfrm>
-            <a:off x="3840480" y="1783080"/>
+            <a:off x="8571738" y="2002536"/>
             <a:ext cx="2057400" cy="841248"/>
           </a:xfrm>
           <a:prstGeom prst="roundRect">
@@ -3626,32 +3445,7 @@
           </a:ln>
         </p:spPr>
         <p:txBody>
-          <a:bodyPr/>
-          <a:lstStyle/>
-          <a:p>
-            <a:endParaRPr lang="ja-JP" altLang="en-US"/>
-          </a:p>
-        </p:txBody>
-      </p:sp>
-      <p:sp>
-        <p:nvSpPr>
-          <p:cNvPr id="10" name="Text 8"/>
-          <p:cNvSpPr/>
-          <p:nvPr/>
-        </p:nvSpPr>
-        <p:spPr>
-          <a:xfrm>
-            <a:off x="3913632" y="1828800"/>
-            <a:ext cx="1911096" cy="749808"/>
-          </a:xfrm>
-          <a:prstGeom prst="rect">
-            <a:avLst/>
-          </a:prstGeom>
-          <a:noFill/>
-          <a:ln/>
-        </p:spPr>
-        <p:txBody>
-          <a:bodyPr wrap="square" lIns="508" tIns="508" rIns="508" bIns="508" rtlCol="0" anchor="ctr">
+          <a:bodyPr wrap="square" lIns="91440" tIns="45720" rIns="91440" bIns="45720" anchor="ctr">
             <a:normAutofit/>
           </a:bodyPr>
           <a:lstStyle/>
@@ -3660,7 +3454,7 @@
               <a:buNone/>
             </a:pPr>
             <a:r>
-              <a:rPr lang="en-US" sz="1800" b="1" dirty="0">
+              <a:rPr lang="en-US" sz="1800" b="1">
                 <a:solidFill>
                   <a:srgbClr val="202124"/>
                 </a:solidFill>
@@ -3670,14 +3464,14 @@
               </a:rPr>
               <a:t>実物の良否</a:t>
             </a:r>
-            <a:endParaRPr lang="en-US" sz="1800" dirty="0"/>
+            <a:endParaRPr lang="en-US" sz="1800"/>
           </a:p>
           <a:p>
             <a:pPr marL="0" indent="0" algn="ctr">
               <a:buNone/>
             </a:pPr>
             <a:r>
-              <a:rPr lang="en-US" sz="1800" b="1" dirty="0">
+              <a:rPr lang="en-US" sz="1800" b="1">
                 <a:solidFill>
                   <a:srgbClr val="202124"/>
                 </a:solidFill>
@@ -3687,7 +3481,7 @@
               </a:rPr>
               <a:t>良品 / 不良品</a:t>
             </a:r>
-            <a:endParaRPr lang="en-US" sz="1800" dirty="0"/>
+            <a:endParaRPr lang="en-US" sz="1800"/>
           </a:p>
         </p:txBody>
       </p:sp>
@@ -3699,7 +3493,7 @@
         </p:nvSpPr>
         <p:spPr>
           <a:xfrm>
-            <a:off x="6355080" y="1874520"/>
+            <a:off x="2171700" y="4902200"/>
             <a:ext cx="2057400" cy="658368"/>
           </a:xfrm>
           <a:prstGeom prst="roundRect">
@@ -3718,32 +3512,7 @@
           </a:ln>
         </p:spPr>
         <p:txBody>
-          <a:bodyPr/>
-          <a:lstStyle/>
-          <a:p>
-            <a:endParaRPr lang="ja-JP" altLang="en-US"/>
-          </a:p>
-        </p:txBody>
-      </p:sp>
-      <p:sp>
-        <p:nvSpPr>
-          <p:cNvPr id="12" name="Text 10"/>
-          <p:cNvSpPr/>
-          <p:nvPr/>
-        </p:nvSpPr>
-        <p:spPr>
-          <a:xfrm>
-            <a:off x="6428232" y="1920240"/>
-            <a:ext cx="1911096" cy="566928"/>
-          </a:xfrm>
-          <a:prstGeom prst="rect">
-            <a:avLst/>
-          </a:prstGeom>
-          <a:noFill/>
-          <a:ln/>
-        </p:spPr>
-        <p:txBody>
-          <a:bodyPr wrap="square" lIns="508" tIns="508" rIns="508" bIns="508" rtlCol="0" anchor="ctr">
+          <a:bodyPr wrap="square" lIns="91440" tIns="45720" rIns="91440" bIns="45720" anchor="ctr">
             <a:normAutofit/>
           </a:bodyPr>
           <a:lstStyle/>
@@ -3752,7 +3521,7 @@
               <a:buNone/>
             </a:pPr>
             <a:r>
-              <a:rPr lang="en-US" sz="2000" b="1" dirty="0">
+              <a:rPr lang="en-US" sz="2000" b="1">
                 <a:solidFill>
                   <a:srgbClr val="202124"/>
                 </a:solidFill>
@@ -3762,39 +3531,7 @@
               </a:rPr>
               <a:t>推定ID</a:t>
             </a:r>
-            <a:endParaRPr lang="en-US" sz="2000" dirty="0"/>
-          </a:p>
-        </p:txBody>
-      </p:sp>
-      <p:sp>
-        <p:nvSpPr>
-          <p:cNvPr id="13" name="Shape 11"/>
-          <p:cNvSpPr/>
-          <p:nvPr/>
-        </p:nvSpPr>
-        <p:spPr>
-          <a:xfrm>
-            <a:off x="8476488" y="2203704"/>
-            <a:ext cx="941832" cy="0"/>
-          </a:xfrm>
-          <a:prstGeom prst="line">
-            <a:avLst/>
-          </a:prstGeom>
-          <a:noFill/>
-          <a:ln w="25400">
-            <a:solidFill>
-              <a:srgbClr val="5F6368"/>
-            </a:solidFill>
-            <a:prstDash val="solid"/>
-            <a:headEnd type="none"/>
-            <a:tailEnd type="triangle"/>
-          </a:ln>
-        </p:spPr>
-        <p:txBody>
-          <a:bodyPr/>
-          <a:lstStyle/>
-          <a:p>
-            <a:endParaRPr lang="ja-JP" altLang="en-US"/>
+            <a:endParaRPr lang="en-US" sz="2000"/>
           </a:p>
         </p:txBody>
       </p:sp>
@@ -3806,8 +3543,8 @@
         </p:nvSpPr>
         <p:spPr>
           <a:xfrm>
-            <a:off x="9464040" y="1783080"/>
-            <a:ext cx="2057400" cy="841248"/>
+            <a:off x="8077200" y="4902200"/>
+            <a:ext cx="3048000" cy="841248"/>
           </a:xfrm>
           <a:prstGeom prst="roundRect">
             <a:avLst>
@@ -3825,33 +3562,8 @@
           </a:ln>
         </p:spPr>
         <p:txBody>
-          <a:bodyPr/>
-          <a:lstStyle/>
-          <a:p>
-            <a:endParaRPr lang="ja-JP" altLang="en-US"/>
-          </a:p>
-        </p:txBody>
-      </p:sp>
-      <p:sp>
-        <p:nvSpPr>
-          <p:cNvPr id="15" name="Text 13"/>
-          <p:cNvSpPr/>
-          <p:nvPr/>
-        </p:nvSpPr>
-        <p:spPr>
-          <a:xfrm>
-            <a:off x="9537192" y="1828800"/>
-            <a:ext cx="1911096" cy="749808"/>
-          </a:xfrm>
-          <a:prstGeom prst="rect">
-            <a:avLst/>
-          </a:prstGeom>
-          <a:noFill/>
-          <a:ln/>
-        </p:spPr>
-        <p:txBody>
-          <a:bodyPr wrap="square" lIns="508" tIns="508" rIns="508" bIns="508" rtlCol="0" anchor="ctr">
-            <a:normAutofit/>
+          <a:bodyPr wrap="square" lIns="91440" tIns="45720" rIns="91440" bIns="45720" anchor="ctr">
+            <a:normAutofit fontScale="92500" lnSpcReduction="10000"/>
           </a:bodyPr>
           <a:lstStyle/>
           <a:p>
@@ -3884,7 +3596,51 @@
                 <a:ea typeface="Noto Sans CJK JP" pitchFamily="34" charset="-122"/>
                 <a:cs typeface="Noto Sans CJK JP" pitchFamily="34" charset="-120"/>
               </a:rPr>
-              <a:t>OK / NG / RETRY</a:t>
+              <a:t>OK</a:t>
+            </a:r>
+            <a:r>
+              <a:rPr lang="ja-JP" altLang="en-US" sz="1700" b="1" dirty="0">
+                <a:solidFill>
+                  <a:srgbClr val="202124"/>
+                </a:solidFill>
+                <a:latin typeface="Noto Sans CJK JP" pitchFamily="34" charset="0"/>
+                <a:ea typeface="Noto Sans CJK JP" pitchFamily="34" charset="-122"/>
+                <a:cs typeface="Noto Sans CJK JP" pitchFamily="34" charset="-120"/>
+              </a:rPr>
+              <a:t>（良品）</a:t>
+            </a:r>
+            <a:r>
+              <a:rPr lang="en-US" sz="1700" b="1" dirty="0">
+                <a:solidFill>
+                  <a:srgbClr val="202124"/>
+                </a:solidFill>
+                <a:latin typeface="Noto Sans CJK JP" pitchFamily="34" charset="0"/>
+                <a:ea typeface="Noto Sans CJK JP" pitchFamily="34" charset="-122"/>
+                <a:cs typeface="Noto Sans CJK JP" pitchFamily="34" charset="-120"/>
+              </a:rPr>
+              <a:t> / NG</a:t>
+            </a:r>
+            <a:r>
+              <a:rPr lang="ja-JP" altLang="en-US" sz="1700" b="1" dirty="0">
+                <a:solidFill>
+                  <a:srgbClr val="202124"/>
+                </a:solidFill>
+                <a:latin typeface="Noto Sans CJK JP" pitchFamily="34" charset="0"/>
+                <a:ea typeface="Noto Sans CJK JP" pitchFamily="34" charset="-122"/>
+                <a:cs typeface="Noto Sans CJK JP" pitchFamily="34" charset="-120"/>
+              </a:rPr>
+              <a:t>（不良品）</a:t>
+            </a:r>
+            <a:r>
+              <a:rPr lang="en-US" sz="1700" b="1" dirty="0">
+                <a:solidFill>
+                  <a:srgbClr val="202124"/>
+                </a:solidFill>
+                <a:latin typeface="Noto Sans CJK JP" pitchFamily="34" charset="0"/>
+                <a:ea typeface="Noto Sans CJK JP" pitchFamily="34" charset="-122"/>
+                <a:cs typeface="Noto Sans CJK JP" pitchFamily="34" charset="-120"/>
+              </a:rPr>
+              <a:t> / RETRY</a:t>
             </a:r>
             <a:endParaRPr lang="en-US" sz="1700" dirty="0"/>
           </a:p>
@@ -3898,8 +3654,8 @@
         </p:nvSpPr>
         <p:spPr>
           <a:xfrm>
-            <a:off x="777240" y="2971800"/>
-            <a:ext cx="3520440" cy="1005840"/>
+            <a:off x="1295400" y="3429000"/>
+            <a:ext cx="3810000" cy="1005840"/>
           </a:xfrm>
           <a:prstGeom prst="roundRect">
             <a:avLst>
@@ -3917,71 +3673,7 @@
           </a:ln>
         </p:spPr>
         <p:txBody>
-          <a:bodyPr/>
-          <a:lstStyle/>
-          <a:p>
-            <a:endParaRPr lang="ja-JP" altLang="en-US"/>
-          </a:p>
-        </p:txBody>
-      </p:sp>
-      <p:sp>
-        <p:nvSpPr>
-          <p:cNvPr id="17" name="Text 15"/>
-          <p:cNvSpPr/>
-          <p:nvPr/>
-        </p:nvSpPr>
-        <p:spPr>
-          <a:xfrm>
-            <a:off x="960120" y="3182112"/>
-            <a:ext cx="1188720" cy="310896"/>
-          </a:xfrm>
-          <a:prstGeom prst="rect">
-            <a:avLst/>
-          </a:prstGeom>
-          <a:noFill/>
-          <a:ln/>
-        </p:spPr>
-        <p:txBody>
-          <a:bodyPr wrap="square" lIns="0" tIns="0" rIns="0" bIns="0" rtlCol="0" anchor="ctr"/>
-          <a:lstStyle/>
-          <a:p>
-            <a:pPr marL="0" indent="0">
-              <a:buNone/>
-            </a:pPr>
-            <a:r>
-              <a:rPr lang="en-US" sz="1900" b="1" dirty="0">
-                <a:solidFill>
-                  <a:srgbClr val="2F75B5"/>
-                </a:solidFill>
-                <a:latin typeface="Noto Sans CJK JP" pitchFamily="34" charset="0"/>
-                <a:ea typeface="Noto Sans CJK JP" pitchFamily="34" charset="-122"/>
-                <a:cs typeface="Noto Sans CJK JP" pitchFamily="34" charset="-120"/>
-              </a:rPr>
-              <a:t>ID一致</a:t>
-            </a:r>
-            <a:endParaRPr lang="en-US" sz="1900" dirty="0"/>
-          </a:p>
-        </p:txBody>
-      </p:sp>
-      <p:sp>
-        <p:nvSpPr>
-          <p:cNvPr id="18" name="Text 16"/>
-          <p:cNvSpPr/>
-          <p:nvPr/>
-        </p:nvSpPr>
-        <p:spPr>
-          <a:xfrm>
-            <a:off x="2057400" y="3191256"/>
-            <a:ext cx="1965960" cy="310896"/>
-          </a:xfrm>
-          <a:prstGeom prst="rect">
-            <a:avLst/>
-          </a:prstGeom>
-          <a:noFill/>
-          <a:ln/>
-        </p:spPr>
-        <p:txBody>
-          <a:bodyPr wrap="square" lIns="0" tIns="0" rIns="0" bIns="0" rtlCol="0" anchor="ctr">
+          <a:bodyPr wrap="square" lIns="91440" tIns="45720" rIns="91440" bIns="45720" anchor="ctr">
             <a:normAutofit/>
           </a:bodyPr>
           <a:lstStyle/>
@@ -3990,6 +3682,34 @@
               <a:buNone/>
             </a:pPr>
             <a:r>
+              <a:rPr lang="en-US" sz="1900" b="1" dirty="0" err="1">
+                <a:solidFill>
+                  <a:srgbClr val="2F75B5"/>
+                </a:solidFill>
+                <a:latin typeface="Noto Sans CJK JP" pitchFamily="34" charset="0"/>
+                <a:ea typeface="Noto Sans CJK JP" pitchFamily="34" charset="-122"/>
+                <a:cs typeface="Noto Sans CJK JP" pitchFamily="34" charset="-120"/>
+              </a:rPr>
+              <a:t>ID一致</a:t>
+            </a:r>
+            <a:endParaRPr lang="en-US" sz="1900" dirty="0"/>
+          </a:p>
+          <a:p>
+            <a:pPr marL="0" indent="0">
+              <a:buNone/>
+            </a:pPr>
+            <a:r>
+              <a:rPr lang="en-US" sz="1500" dirty="0" err="1">
+                <a:solidFill>
+                  <a:srgbClr val="202124"/>
+                </a:solidFill>
+                <a:latin typeface="Noto Sans CJK JP" pitchFamily="34" charset="0"/>
+                <a:ea typeface="Noto Sans CJK JP" pitchFamily="34" charset="-122"/>
+                <a:cs typeface="Noto Sans CJK JP" pitchFamily="34" charset="-120"/>
+              </a:rPr>
+              <a:t>正解ID</a:t>
+            </a:r>
+            <a:r>
               <a:rPr lang="en-US" sz="1500" dirty="0">
                 <a:solidFill>
                   <a:srgbClr val="202124"/>
@@ -3998,7 +3718,40 @@
                 <a:ea typeface="Noto Sans CJK JP" pitchFamily="34" charset="-122"/>
                 <a:cs typeface="Noto Sans CJK JP" pitchFamily="34" charset="-120"/>
               </a:rPr>
-              <a:t>正解ID と 推定ID を比較</a:t>
+              <a:t> と </a:t>
+            </a:r>
+            <a:r>
+              <a:rPr lang="en-US" sz="1500" dirty="0" err="1">
+                <a:solidFill>
+                  <a:srgbClr val="202124"/>
+                </a:solidFill>
+                <a:latin typeface="Noto Sans CJK JP" pitchFamily="34" charset="0"/>
+                <a:ea typeface="Noto Sans CJK JP" pitchFamily="34" charset="-122"/>
+                <a:cs typeface="Noto Sans CJK JP" pitchFamily="34" charset="-120"/>
+              </a:rPr>
+              <a:t>推定ID</a:t>
+            </a:r>
+            <a:r>
+              <a:rPr lang="en-US" sz="1500" dirty="0">
+                <a:solidFill>
+                  <a:srgbClr val="202124"/>
+                </a:solidFill>
+                <a:latin typeface="Noto Sans CJK JP" pitchFamily="34" charset="0"/>
+                <a:ea typeface="Noto Sans CJK JP" pitchFamily="34" charset="-122"/>
+                <a:cs typeface="Noto Sans CJK JP" pitchFamily="34" charset="-120"/>
+              </a:rPr>
+              <a:t> </a:t>
+            </a:r>
+            <a:r>
+              <a:rPr lang="ja-JP" altLang="en-US" sz="1500" dirty="0">
+                <a:solidFill>
+                  <a:srgbClr val="202124"/>
+                </a:solidFill>
+                <a:latin typeface="Noto Sans CJK JP" pitchFamily="34" charset="0"/>
+                <a:ea typeface="Noto Sans CJK JP" pitchFamily="34" charset="-122"/>
+                <a:cs typeface="Noto Sans CJK JP" pitchFamily="34" charset="-120"/>
+              </a:rPr>
+              <a:t>があっていること</a:t>
             </a:r>
             <a:endParaRPr lang="en-US" sz="1500" dirty="0"/>
           </a:p>
@@ -4012,7 +3765,7 @@
         </p:nvSpPr>
         <p:spPr>
           <a:xfrm>
-            <a:off x="4498848" y="2971800"/>
+            <a:off x="7611618" y="3352800"/>
             <a:ext cx="3977640" cy="1005840"/>
           </a:xfrm>
           <a:prstGeom prst="roundRect">
@@ -4031,71 +3784,7 @@
           </a:ln>
         </p:spPr>
         <p:txBody>
-          <a:bodyPr/>
-          <a:lstStyle/>
-          <a:p>
-            <a:endParaRPr lang="ja-JP" altLang="en-US"/>
-          </a:p>
-        </p:txBody>
-      </p:sp>
-      <p:sp>
-        <p:nvSpPr>
-          <p:cNvPr id="20" name="Text 18"/>
-          <p:cNvSpPr/>
-          <p:nvPr/>
-        </p:nvSpPr>
-        <p:spPr>
-          <a:xfrm>
-            <a:off x="4681728" y="3182112"/>
-            <a:ext cx="1783080" cy="310896"/>
-          </a:xfrm>
-          <a:prstGeom prst="rect">
-            <a:avLst/>
-          </a:prstGeom>
-          <a:noFill/>
-          <a:ln/>
-        </p:spPr>
-        <p:txBody>
-          <a:bodyPr wrap="square" lIns="0" tIns="0" rIns="0" bIns="0" rtlCol="0" anchor="ctr"/>
-          <a:lstStyle/>
-          <a:p>
-            <a:pPr marL="0" indent="0">
-              <a:buNone/>
-            </a:pPr>
-            <a:r>
-              <a:rPr lang="en-US" sz="1900" b="1" dirty="0">
-                <a:solidFill>
-                  <a:srgbClr val="2E7D32"/>
-                </a:solidFill>
-                <a:latin typeface="Noto Sans CJK JP" pitchFamily="34" charset="0"/>
-                <a:ea typeface="Noto Sans CJK JP" pitchFamily="34" charset="-122"/>
-                <a:cs typeface="Noto Sans CJK JP" pitchFamily="34" charset="-120"/>
-              </a:rPr>
-              <a:t>良否判定の一致</a:t>
-            </a:r>
-            <a:endParaRPr lang="en-US" sz="1900" dirty="0"/>
-          </a:p>
-        </p:txBody>
-      </p:sp>
-      <p:sp>
-        <p:nvSpPr>
-          <p:cNvPr id="21" name="Text 19"/>
-          <p:cNvSpPr/>
-          <p:nvPr/>
-        </p:nvSpPr>
-        <p:spPr>
-          <a:xfrm>
-            <a:off x="6455664" y="3191256"/>
-            <a:ext cx="1783080" cy="310896"/>
-          </a:xfrm>
-          <a:prstGeom prst="rect">
-            <a:avLst/>
-          </a:prstGeom>
-          <a:noFill/>
-          <a:ln/>
-        </p:spPr>
-        <p:txBody>
-          <a:bodyPr wrap="square" lIns="0" tIns="0" rIns="0" bIns="0" rtlCol="0" anchor="ctr">
+          <a:bodyPr wrap="square" lIns="91440" tIns="45720" rIns="91440" bIns="45720" anchor="ctr">
             <a:normAutofit/>
           </a:bodyPr>
           <a:lstStyle/>
@@ -4104,6 +3793,34 @@
               <a:buNone/>
             </a:pPr>
             <a:r>
+              <a:rPr lang="en-US" sz="1900" b="1" dirty="0" err="1">
+                <a:solidFill>
+                  <a:srgbClr val="2E7D32"/>
+                </a:solidFill>
+                <a:latin typeface="Noto Sans CJK JP" pitchFamily="34" charset="0"/>
+                <a:ea typeface="Noto Sans CJK JP" pitchFamily="34" charset="-122"/>
+                <a:cs typeface="Noto Sans CJK JP" pitchFamily="34" charset="-120"/>
+              </a:rPr>
+              <a:t>良否判定の一致</a:t>
+            </a:r>
+            <a:endParaRPr lang="en-US" sz="1900" dirty="0"/>
+          </a:p>
+          <a:p>
+            <a:pPr marL="0" indent="0">
+              <a:buNone/>
+            </a:pPr>
+            <a:r>
+              <a:rPr lang="en-US" sz="1450" dirty="0" err="1">
+                <a:solidFill>
+                  <a:srgbClr val="202124"/>
+                </a:solidFill>
+                <a:latin typeface="Noto Sans CJK JP" pitchFamily="34" charset="0"/>
+                <a:ea typeface="Noto Sans CJK JP" pitchFamily="34" charset="-122"/>
+                <a:cs typeface="Noto Sans CJK JP" pitchFamily="34" charset="-120"/>
+              </a:rPr>
+              <a:t>実物の良否</a:t>
+            </a:r>
+            <a:r>
               <a:rPr lang="en-US" sz="1450" dirty="0">
                 <a:solidFill>
                   <a:srgbClr val="202124"/>
@@ -4112,7 +3829,42 @@
                 <a:ea typeface="Noto Sans CJK JP" pitchFamily="34" charset="-122"/>
                 <a:cs typeface="Noto Sans CJK JP" pitchFamily="34" charset="-120"/>
               </a:rPr>
-              <a:t>実物の良否 と M5判定 を比較</a:t>
+              <a:t> と M5</a:t>
+            </a:r>
+            <a:r>
+              <a:rPr lang="ja-JP" altLang="en-US" sz="1450" dirty="0">
+                <a:solidFill>
+                  <a:srgbClr val="202124"/>
+                </a:solidFill>
+                <a:latin typeface="Noto Sans CJK JP" pitchFamily="34" charset="0"/>
+                <a:ea typeface="Noto Sans CJK JP" pitchFamily="34" charset="-122"/>
+                <a:cs typeface="Noto Sans CJK JP" pitchFamily="34" charset="-120"/>
+              </a:rPr>
+              <a:t>の良品／不良品判定が</a:t>
+            </a:r>
+            <a:endParaRPr lang="en-US" altLang="ja-JP" sz="1450" dirty="0">
+              <a:solidFill>
+                <a:srgbClr val="202124"/>
+              </a:solidFill>
+              <a:latin typeface="Noto Sans CJK JP" pitchFamily="34" charset="0"/>
+              <a:ea typeface="Noto Sans CJK JP" pitchFamily="34" charset="-122"/>
+              <a:cs typeface="Noto Sans CJK JP" pitchFamily="34" charset="-120"/>
+            </a:endParaRPr>
+          </a:p>
+          <a:p>
+            <a:pPr marL="0" indent="0">
+              <a:buNone/>
+            </a:pPr>
+            <a:r>
+              <a:rPr lang="ja-JP" altLang="en-US" sz="1450" dirty="0">
+                <a:solidFill>
+                  <a:srgbClr val="202124"/>
+                </a:solidFill>
+                <a:latin typeface="Noto Sans CJK JP" pitchFamily="34" charset="0"/>
+                <a:ea typeface="Noto Sans CJK JP" pitchFamily="34" charset="-122"/>
+                <a:cs typeface="Noto Sans CJK JP" pitchFamily="34" charset="-120"/>
+              </a:rPr>
+              <a:t>あっていること</a:t>
             </a:r>
             <a:endParaRPr lang="en-US" sz="1450" dirty="0"/>
           </a:p>
@@ -4126,8 +3878,8 @@
         </p:nvSpPr>
         <p:spPr>
           <a:xfrm>
-            <a:off x="8668512" y="2971800"/>
-            <a:ext cx="2606040" cy="1005840"/>
+            <a:off x="5257800" y="4800600"/>
+            <a:ext cx="2057400" cy="1005840"/>
           </a:xfrm>
           <a:prstGeom prst="roundRect">
             <a:avLst>
@@ -4135,7 +3887,7 @@
             </a:avLst>
           </a:prstGeom>
           <a:solidFill>
-            <a:srgbClr val="FFFFFF"/>
+            <a:schemeClr val="bg1"/>
           </a:solidFill>
           <a:ln w="12700">
             <a:solidFill>
@@ -4145,39 +3897,16 @@
           </a:ln>
         </p:spPr>
         <p:txBody>
-          <a:bodyPr/>
-          <a:lstStyle/>
-          <a:p>
-            <a:endParaRPr lang="ja-JP" altLang="en-US"/>
-          </a:p>
-        </p:txBody>
-      </p:sp>
-      <p:sp>
-        <p:nvSpPr>
-          <p:cNvPr id="23" name="Text 21"/>
-          <p:cNvSpPr/>
-          <p:nvPr/>
-        </p:nvSpPr>
-        <p:spPr>
-          <a:xfrm>
-            <a:off x="8869680" y="3182112"/>
-            <a:ext cx="960120" cy="310896"/>
-          </a:xfrm>
-          <a:prstGeom prst="rect">
-            <a:avLst/>
-          </a:prstGeom>
-          <a:noFill/>
-          <a:ln/>
-        </p:spPr>
-        <p:txBody>
-          <a:bodyPr wrap="square" lIns="0" tIns="0" rIns="0" bIns="0" rtlCol="0" anchor="ctr"/>
+          <a:bodyPr wrap="square" lIns="91440" tIns="45720" rIns="91440" bIns="45720" anchor="ctr">
+            <a:normAutofit/>
+          </a:bodyPr>
           <a:lstStyle/>
           <a:p>
             <a:pPr marL="0" indent="0">
               <a:buNone/>
             </a:pPr>
             <a:r>
-              <a:rPr lang="en-US" sz="1900" b="1" dirty="0">
+              <a:rPr lang="en-US" sz="1900" b="1" dirty="0" err="1">
                 <a:solidFill>
                   <a:srgbClr val="B3261E"/>
                 </a:solidFill>
@@ -4189,18 +3918,85 @@
             </a:r>
             <a:endParaRPr lang="en-US" sz="1900" dirty="0"/>
           </a:p>
-        </p:txBody>
-      </p:sp>
-      <p:sp>
-        <p:nvSpPr>
-          <p:cNvPr id="24" name="Text 22"/>
-          <p:cNvSpPr/>
-          <p:nvPr/>
-        </p:nvSpPr>
-        <p:spPr>
-          <a:xfrm>
-            <a:off x="9802368" y="3072384"/>
-            <a:ext cx="1280160" cy="530352"/>
+          <a:p>
+            <a:pPr marL="0" indent="0">
+              <a:buNone/>
+            </a:pPr>
+            <a:r>
+              <a:rPr lang="en-US" sz="1350" dirty="0">
+                <a:solidFill>
+                  <a:srgbClr val="202124"/>
+                </a:solidFill>
+                <a:latin typeface="Noto Sans CJK JP" pitchFamily="34" charset="0"/>
+                <a:ea typeface="Noto Sans CJK JP" pitchFamily="34" charset="-122"/>
+                <a:cs typeface="Noto Sans CJK JP" pitchFamily="34" charset="-120"/>
+              </a:rPr>
+              <a:t>IR</a:t>
+            </a:r>
+            <a:r>
+              <a:rPr lang="ja-JP" altLang="en-US" sz="1350" dirty="0">
+                <a:solidFill>
+                  <a:srgbClr val="202124"/>
+                </a:solidFill>
+                <a:latin typeface="Noto Sans CJK JP" pitchFamily="34" charset="0"/>
+                <a:ea typeface="Noto Sans CJK JP" pitchFamily="34" charset="-122"/>
+                <a:cs typeface="Noto Sans CJK JP" pitchFamily="34" charset="-120"/>
+              </a:rPr>
+              <a:t> センサー</a:t>
+            </a:r>
+            <a:r>
+              <a:rPr lang="en-US" sz="1350" dirty="0" err="1">
+                <a:solidFill>
+                  <a:srgbClr val="202124"/>
+                </a:solidFill>
+                <a:latin typeface="Noto Sans CJK JP" pitchFamily="34" charset="0"/>
+                <a:ea typeface="Noto Sans CJK JP" pitchFamily="34" charset="-122"/>
+                <a:cs typeface="Noto Sans CJK JP" pitchFamily="34" charset="-120"/>
+              </a:rPr>
+              <a:t>反応なし</a:t>
+            </a:r>
+            <a:endParaRPr lang="en-US" sz="1350" dirty="0"/>
+          </a:p>
+          <a:p>
+            <a:pPr marL="0" indent="0">
+              <a:buNone/>
+            </a:pPr>
+            <a:r>
+              <a:rPr lang="en-US" sz="1350" dirty="0" err="1">
+                <a:solidFill>
+                  <a:srgbClr val="202124"/>
+                </a:solidFill>
+                <a:latin typeface="Noto Sans CJK JP" pitchFamily="34" charset="0"/>
+                <a:ea typeface="Noto Sans CJK JP" pitchFamily="34" charset="-122"/>
+                <a:cs typeface="Noto Sans CJK JP" pitchFamily="34" charset="-120"/>
+              </a:rPr>
+              <a:t>または</a:t>
+            </a:r>
+            <a:r>
+              <a:rPr lang="en-US" sz="1350" dirty="0">
+                <a:solidFill>
+                  <a:srgbClr val="202124"/>
+                </a:solidFill>
+                <a:latin typeface="Noto Sans CJK JP" pitchFamily="34" charset="0"/>
+                <a:ea typeface="Noto Sans CJK JP" pitchFamily="34" charset="-122"/>
+                <a:cs typeface="Noto Sans CJK JP" pitchFamily="34" charset="-120"/>
+              </a:rPr>
+              <a:t> ID=0 → RETRY</a:t>
+            </a:r>
+            <a:endParaRPr lang="en-US" sz="1350" dirty="0"/>
+          </a:p>
+        </p:txBody>
+      </p:sp>
+      <p:sp>
+        <p:nvSpPr>
+          <p:cNvPr id="34" name="Text 32"/>
+          <p:cNvSpPr/>
+          <p:nvPr/>
+        </p:nvSpPr>
+        <p:spPr>
+          <a:xfrm>
+            <a:off x="1389888" y="6428232"/>
+            <a:ext cx="10332720" cy="347472"/>
           </a:xfrm>
           <a:prstGeom prst="rect">
             <a:avLst/>
@@ -4214,408 +4010,21 @@
           </a:bodyPr>
           <a:lstStyle/>
           <a:p>
-            <a:pPr marL="0" indent="0">
-              <a:buNone/>
-            </a:pPr>
-            <a:r>
-              <a:rPr lang="en-US" sz="1350" dirty="0">
-                <a:solidFill>
-                  <a:srgbClr val="202124"/>
-                </a:solidFill>
-                <a:latin typeface="Noto Sans CJK JP" pitchFamily="34" charset="0"/>
-                <a:ea typeface="Noto Sans CJK JP" pitchFamily="34" charset="-122"/>
-                <a:cs typeface="Noto Sans CJK JP" pitchFamily="34" charset="-120"/>
-              </a:rPr>
-              <a:t>IR反応なし</a:t>
-            </a:r>
-            <a:endParaRPr lang="en-US" sz="1350" dirty="0"/>
-          </a:p>
-          <a:p>
-            <a:pPr marL="0" indent="0">
-              <a:buNone/>
-            </a:pPr>
-            <a:r>
-              <a:rPr lang="en-US" sz="1350" dirty="0">
-                <a:solidFill>
-                  <a:srgbClr val="202124"/>
-                </a:solidFill>
-                <a:latin typeface="Noto Sans CJK JP" pitchFamily="34" charset="0"/>
-                <a:ea typeface="Noto Sans CJK JP" pitchFamily="34" charset="-122"/>
-                <a:cs typeface="Noto Sans CJK JP" pitchFamily="34" charset="-120"/>
-              </a:rPr>
-              <a:t>または ID=0 → RETRY</a:t>
-            </a:r>
-            <a:endParaRPr lang="en-US" sz="1350" dirty="0"/>
-          </a:p>
-        </p:txBody>
-      </p:sp>
-      <p:sp>
-        <p:nvSpPr>
-          <p:cNvPr id="25" name="Shape 23"/>
-          <p:cNvSpPr/>
-          <p:nvPr/>
-        </p:nvSpPr>
-        <p:spPr>
-          <a:xfrm>
-            <a:off x="868680" y="4343400"/>
-            <a:ext cx="3429000" cy="1188720"/>
-          </a:xfrm>
-          <a:prstGeom prst="roundRect">
-            <a:avLst>
-              <a:gd name="adj" fmla="val 6154"/>
-            </a:avLst>
-          </a:prstGeom>
-          <a:solidFill>
-            <a:srgbClr val="EAF5EC"/>
-          </a:solidFill>
-          <a:ln w="12700">
-            <a:solidFill>
-              <a:srgbClr val="2E7D32"/>
-            </a:solidFill>
-            <a:prstDash val="solid"/>
-          </a:ln>
-        </p:spPr>
-        <p:txBody>
-          <a:bodyPr/>
-          <a:lstStyle/>
-          <a:p>
-            <a:endParaRPr lang="ja-JP" altLang="en-US"/>
-          </a:p>
-        </p:txBody>
-      </p:sp>
-      <p:sp>
-        <p:nvSpPr>
-          <p:cNvPr id="26" name="Text 24"/>
-          <p:cNvSpPr/>
-          <p:nvPr/>
-        </p:nvSpPr>
-        <p:spPr>
-          <a:xfrm>
-            <a:off x="1078992" y="4507992"/>
-            <a:ext cx="3017520" cy="256032"/>
-          </a:xfrm>
-          <a:prstGeom prst="rect">
-            <a:avLst/>
-          </a:prstGeom>
-          <a:noFill/>
-          <a:ln/>
-        </p:spPr>
-        <p:txBody>
-          <a:bodyPr wrap="square" lIns="0" tIns="0" rIns="0" bIns="0" rtlCol="0" anchor="ctr"/>
-          <a:lstStyle/>
-          <a:p>
-            <a:pPr marL="0" indent="0">
-              <a:buNone/>
-            </a:pPr>
-            <a:r>
-              <a:rPr lang="en-US" sz="1600" b="1" dirty="0">
-                <a:solidFill>
-                  <a:srgbClr val="202124"/>
-                </a:solidFill>
-                <a:latin typeface="Noto Sans CJK JP" pitchFamily="34" charset="0"/>
-                <a:ea typeface="Noto Sans CJK JP" pitchFamily="34" charset="-122"/>
-                <a:cs typeface="Noto Sans CJK JP" pitchFamily="34" charset="-120"/>
-              </a:rPr>
-              <a:t>例 A  正解ID 3 → 推定ID 4</a:t>
-            </a:r>
-            <a:endParaRPr lang="en-US" sz="1600" dirty="0"/>
-          </a:p>
-        </p:txBody>
-      </p:sp>
-      <p:sp>
-        <p:nvSpPr>
-          <p:cNvPr id="27" name="Text 25"/>
-          <p:cNvSpPr/>
-          <p:nvPr/>
-        </p:nvSpPr>
-        <p:spPr>
-          <a:xfrm>
-            <a:off x="1078992" y="4901184"/>
-            <a:ext cx="3017520" cy="274320"/>
-          </a:xfrm>
-          <a:prstGeom prst="rect">
-            <a:avLst/>
-          </a:prstGeom>
-          <a:noFill/>
-          <a:ln/>
-        </p:spPr>
-        <p:txBody>
-          <a:bodyPr wrap="square" lIns="0" tIns="0" rIns="0" bIns="0" rtlCol="0" anchor="ctr">
-            <a:normAutofit/>
-          </a:bodyPr>
-          <a:lstStyle/>
-          <a:p>
-            <a:pPr marL="0" indent="0">
-              <a:buNone/>
-            </a:pPr>
-            <a:r>
-              <a:rPr lang="en-US" sz="1450" dirty="0">
-                <a:solidFill>
-                  <a:srgbClr val="202124"/>
-                </a:solidFill>
-                <a:latin typeface="Noto Sans CJK JP" pitchFamily="34" charset="0"/>
-                <a:ea typeface="Noto Sans CJK JP" pitchFamily="34" charset="-122"/>
-                <a:cs typeface="Noto Sans CJK JP" pitchFamily="34" charset="-120"/>
-              </a:rPr>
-              <a:t>ID一致：×　良否判定：○　見逃し：なし</a:t>
-            </a:r>
-            <a:endParaRPr lang="en-US" sz="1450" dirty="0"/>
-          </a:p>
-        </p:txBody>
-      </p:sp>
-      <p:sp>
-        <p:nvSpPr>
-          <p:cNvPr id="28" name="Shape 26"/>
-          <p:cNvSpPr/>
-          <p:nvPr/>
-        </p:nvSpPr>
-        <p:spPr>
-          <a:xfrm>
-            <a:off x="4434840" y="4343400"/>
-            <a:ext cx="3429000" cy="1188720"/>
-          </a:xfrm>
-          <a:prstGeom prst="roundRect">
-            <a:avLst>
-              <a:gd name="adj" fmla="val 6154"/>
-            </a:avLst>
-          </a:prstGeom>
-          <a:solidFill>
-            <a:srgbClr val="FCE8E6"/>
-          </a:solidFill>
-          <a:ln w="12700">
-            <a:solidFill>
-              <a:srgbClr val="B3261E"/>
-            </a:solidFill>
-            <a:prstDash val="solid"/>
-          </a:ln>
-        </p:spPr>
-        <p:txBody>
-          <a:bodyPr/>
-          <a:lstStyle/>
-          <a:p>
-            <a:endParaRPr lang="ja-JP" altLang="en-US"/>
-          </a:p>
-        </p:txBody>
-      </p:sp>
-      <p:sp>
-        <p:nvSpPr>
-          <p:cNvPr id="29" name="Text 27"/>
-          <p:cNvSpPr/>
-          <p:nvPr/>
-        </p:nvSpPr>
-        <p:spPr>
-          <a:xfrm>
-            <a:off x="4645152" y="4507992"/>
-            <a:ext cx="3017520" cy="256032"/>
-          </a:xfrm>
-          <a:prstGeom prst="rect">
-            <a:avLst/>
-          </a:prstGeom>
-          <a:noFill/>
-          <a:ln/>
-        </p:spPr>
-        <p:txBody>
-          <a:bodyPr wrap="square" lIns="0" tIns="0" rIns="0" bIns="0" rtlCol="0" anchor="ctr"/>
-          <a:lstStyle/>
-          <a:p>
-            <a:pPr marL="0" indent="0">
-              <a:buNone/>
-            </a:pPr>
-            <a:r>
-              <a:rPr lang="en-US" sz="1600" b="1" dirty="0">
-                <a:solidFill>
-                  <a:srgbClr val="202124"/>
-                </a:solidFill>
-                <a:latin typeface="Noto Sans CJK JP" pitchFamily="34" charset="0"/>
-                <a:ea typeface="Noto Sans CJK JP" pitchFamily="34" charset="-122"/>
-                <a:cs typeface="Noto Sans CJK JP" pitchFamily="34" charset="-120"/>
-              </a:rPr>
-              <a:t>例 B  正解ID 3 → 推定ID 1</a:t>
-            </a:r>
-            <a:endParaRPr lang="en-US" sz="1600" dirty="0"/>
-          </a:p>
-        </p:txBody>
-      </p:sp>
-      <p:sp>
-        <p:nvSpPr>
-          <p:cNvPr id="30" name="Text 28"/>
-          <p:cNvSpPr/>
-          <p:nvPr/>
-        </p:nvSpPr>
-        <p:spPr>
-          <a:xfrm>
-            <a:off x="4645152" y="4901184"/>
-            <a:ext cx="3017520" cy="274320"/>
-          </a:xfrm>
-          <a:prstGeom prst="rect">
-            <a:avLst/>
-          </a:prstGeom>
-          <a:noFill/>
-          <a:ln/>
-        </p:spPr>
-        <p:txBody>
-          <a:bodyPr wrap="square" lIns="0" tIns="0" rIns="0" bIns="0" rtlCol="0" anchor="ctr">
-            <a:normAutofit/>
-          </a:bodyPr>
-          <a:lstStyle/>
-          <a:p>
-            <a:pPr marL="0" indent="0">
-              <a:buNone/>
-            </a:pPr>
-            <a:r>
-              <a:rPr lang="en-US" sz="1450" dirty="0">
-                <a:solidFill>
-                  <a:srgbClr val="202124"/>
-                </a:solidFill>
-                <a:latin typeface="Noto Sans CJK JP" pitchFamily="34" charset="0"/>
-                <a:ea typeface="Noto Sans CJK JP" pitchFamily="34" charset="-122"/>
-                <a:cs typeface="Noto Sans CJK JP" pitchFamily="34" charset="-120"/>
-              </a:rPr>
-              <a:t>ID一致：×　良否判定：×　見逃し：なし</a:t>
-            </a:r>
-            <a:endParaRPr lang="en-US" sz="1450" dirty="0"/>
-          </a:p>
-        </p:txBody>
-      </p:sp>
-      <p:sp>
-        <p:nvSpPr>
-          <p:cNvPr id="31" name="Shape 29"/>
-          <p:cNvSpPr/>
-          <p:nvPr/>
-        </p:nvSpPr>
-        <p:spPr>
-          <a:xfrm>
-            <a:off x="8001000" y="4343400"/>
-            <a:ext cx="3291840" cy="1188720"/>
-          </a:xfrm>
-          <a:prstGeom prst="roundRect">
-            <a:avLst>
-              <a:gd name="adj" fmla="val 6154"/>
-            </a:avLst>
-          </a:prstGeom>
-          <a:solidFill>
-            <a:srgbClr val="FBE9DD"/>
-          </a:solidFill>
-          <a:ln w="12700">
-            <a:solidFill>
-              <a:srgbClr val="C55A11"/>
-            </a:solidFill>
-            <a:prstDash val="solid"/>
-          </a:ln>
-        </p:spPr>
-        <p:txBody>
-          <a:bodyPr/>
-          <a:lstStyle/>
-          <a:p>
-            <a:endParaRPr lang="ja-JP" altLang="en-US"/>
-          </a:p>
-        </p:txBody>
-      </p:sp>
-      <p:sp>
-        <p:nvSpPr>
-          <p:cNvPr id="32" name="Text 30"/>
-          <p:cNvSpPr/>
-          <p:nvPr/>
-        </p:nvSpPr>
-        <p:spPr>
-          <a:xfrm>
-            <a:off x="8211312" y="4507992"/>
-            <a:ext cx="2880360" cy="256032"/>
-          </a:xfrm>
-          <a:prstGeom prst="rect">
-            <a:avLst/>
-          </a:prstGeom>
-          <a:noFill/>
-          <a:ln/>
-        </p:spPr>
-        <p:txBody>
-          <a:bodyPr wrap="square" lIns="0" tIns="0" rIns="0" bIns="0" rtlCol="0" anchor="ctr"/>
-          <a:lstStyle/>
-          <a:p>
-            <a:pPr marL="0" indent="0">
-              <a:buNone/>
-            </a:pPr>
-            <a:r>
-              <a:rPr lang="en-US" sz="1600" b="1" dirty="0">
-                <a:solidFill>
-                  <a:srgbClr val="202124"/>
-                </a:solidFill>
-                <a:latin typeface="Noto Sans CJK JP" pitchFamily="34" charset="0"/>
-                <a:ea typeface="Noto Sans CJK JP" pitchFamily="34" charset="-122"/>
-                <a:cs typeface="Noto Sans CJK JP" pitchFamily="34" charset="-120"/>
-              </a:rPr>
-              <a:t>例 C  IR反応なし / ID=0</a:t>
-            </a:r>
-            <a:endParaRPr lang="en-US" sz="1600" dirty="0"/>
-          </a:p>
-        </p:txBody>
-      </p:sp>
-      <p:sp>
-        <p:nvSpPr>
-          <p:cNvPr id="33" name="Text 31"/>
-          <p:cNvSpPr/>
-          <p:nvPr/>
-        </p:nvSpPr>
-        <p:spPr>
-          <a:xfrm>
-            <a:off x="8211312" y="4901184"/>
-            <a:ext cx="2880360" cy="274320"/>
-          </a:xfrm>
-          <a:prstGeom prst="rect">
-            <a:avLst/>
-          </a:prstGeom>
-          <a:noFill/>
-          <a:ln/>
-        </p:spPr>
-        <p:txBody>
-          <a:bodyPr wrap="square" lIns="0" tIns="0" rIns="0" bIns="0" rtlCol="0" anchor="ctr"/>
-          <a:lstStyle/>
-          <a:p>
-            <a:pPr marL="0" indent="0">
-              <a:buNone/>
-            </a:pPr>
-            <a:r>
-              <a:rPr lang="en-US" sz="1500" dirty="0">
-                <a:solidFill>
-                  <a:srgbClr val="202124"/>
-                </a:solidFill>
-                <a:latin typeface="Noto Sans CJK JP" pitchFamily="34" charset="0"/>
-                <a:ea typeface="Noto Sans CJK JP" pitchFamily="34" charset="-122"/>
-                <a:cs typeface="Noto Sans CJK JP" pitchFamily="34" charset="-120"/>
-              </a:rPr>
-              <a:t>見逃し：あり</a:t>
-            </a:r>
-            <a:endParaRPr lang="en-US" sz="1500" dirty="0"/>
-          </a:p>
-        </p:txBody>
-      </p:sp>
-      <p:sp>
-        <p:nvSpPr>
-          <p:cNvPr id="34" name="Text 32"/>
-          <p:cNvSpPr/>
-          <p:nvPr/>
-        </p:nvSpPr>
-        <p:spPr>
-          <a:xfrm>
-            <a:off x="914400" y="5833872"/>
-            <a:ext cx="10332720" cy="347472"/>
-          </a:xfrm>
-          <a:prstGeom prst="rect">
-            <a:avLst/>
-          </a:prstGeom>
-          <a:noFill/>
-          <a:ln/>
-        </p:spPr>
-        <p:txBody>
-          <a:bodyPr wrap="square" lIns="0" tIns="0" rIns="0" bIns="0" rtlCol="0" anchor="ctr">
-            <a:normAutofit/>
-          </a:bodyPr>
-          <a:lstStyle/>
-          <a:p>
             <a:pPr marL="0" indent="0" algn="ctr">
               <a:buNone/>
             </a:pPr>
             <a:r>
+              <a:rPr lang="en-US" sz="1800" b="1" dirty="0" err="1">
+                <a:solidFill>
+                  <a:srgbClr val="1F4E79"/>
+                </a:solidFill>
+                <a:latin typeface="Noto Sans CJK JP" pitchFamily="34" charset="0"/>
+                <a:ea typeface="Noto Sans CJK JP" pitchFamily="34" charset="-122"/>
+                <a:cs typeface="Noto Sans CJK JP" pitchFamily="34" charset="-120"/>
+              </a:rPr>
+              <a:t>ID一致率が低くても良否判定一致率が高い場合があります</a:t>
+            </a:r>
+            <a:r>
               <a:rPr lang="en-US" sz="1800" b="1" dirty="0">
                 <a:solidFill>
                   <a:srgbClr val="1F4E79"/>
@@ -4624,7 +4033,7 @@
                 <a:ea typeface="Noto Sans CJK JP" pitchFamily="34" charset="-122"/>
                 <a:cs typeface="Noto Sans CJK JP" pitchFamily="34" charset="-120"/>
               </a:rPr>
-              <a:t>例Aのように、ID一致率が低くても良否判定一致率が高い場合があります。</a:t>
+              <a:t>。</a:t>
             </a:r>
             <a:endParaRPr lang="en-US" sz="1800" dirty="0"/>
           </a:p>
@@ -4650,7 +4059,7 @@
           </a:prstGeom>
           <a:extLst>
             <a:ext uri="{C572A759-6A51-4108-AA02-DFA0A04FC94B}">
-              <ma14:wrappingTextBoxFlag xmlns:ma14="http://schemas.microsoft.com/office/mac/drawingml/2011/main" xmlns="" val="0"/>
+              <ma14:wrappingTextBoxFlag xmlns="" xmlns:ma14="http://schemas.microsoft.com/office/mac/drawingml/2011/main" val="0"/>
             </a:ext>
           </a:extLst>
         </p:spPr>
@@ -4675,6 +4084,228 @@
               <a:t>3</a:t>
             </a:fld>
             <a:endParaRPr lang="en-US"/>
+          </a:p>
+        </p:txBody>
+      </p:sp>
+      <p:cxnSp>
+        <p:nvCxnSpPr>
+          <p:cNvPr id="53" name="直線矢印コネクタ 52">
+            <a:extLst>
+              <a:ext uri="{FF2B5EF4-FFF2-40B4-BE49-F238E27FC236}">
+                <a16:creationId xmlns:a16="http://schemas.microsoft.com/office/drawing/2014/main" id="{C9AF130E-4336-FA45-E8EC-A73C1236C794}"/>
+              </a:ext>
+            </a:extLst>
+          </p:cNvPr>
+          <p:cNvCxnSpPr>
+            <a:cxnSpLocks/>
+            <a:stCxn id="6" idx="2"/>
+            <a:endCxn id="16" idx="0"/>
+          </p:cNvCxnSpPr>
+          <p:nvPr/>
+        </p:nvCxnSpPr>
+        <p:spPr>
+          <a:xfrm>
+            <a:off x="3200400" y="2843784"/>
+            <a:ext cx="0" cy="585216"/>
+          </a:xfrm>
+          <a:prstGeom prst="straightConnector1">
+            <a:avLst/>
+          </a:prstGeom>
+          <a:ln>
+            <a:tailEnd type="triangle"/>
+          </a:ln>
+        </p:spPr>
+        <p:style>
+          <a:lnRef idx="1">
+            <a:schemeClr val="accent1"/>
+          </a:lnRef>
+          <a:fillRef idx="0">
+            <a:schemeClr val="accent1"/>
+          </a:fillRef>
+          <a:effectRef idx="0">
+            <a:schemeClr val="accent1"/>
+          </a:effectRef>
+          <a:fontRef idx="minor">
+            <a:schemeClr val="tx1"/>
+          </a:fontRef>
+        </p:style>
+      </p:cxnSp>
+      <p:cxnSp>
+        <p:nvCxnSpPr>
+          <p:cNvPr id="55" name="直線矢印コネクタ 54">
+            <a:extLst>
+              <a:ext uri="{FF2B5EF4-FFF2-40B4-BE49-F238E27FC236}">
+                <a16:creationId xmlns:a16="http://schemas.microsoft.com/office/drawing/2014/main" id="{FE169109-5DEC-6BA4-6866-B43A2E16A200}"/>
+              </a:ext>
+            </a:extLst>
+          </p:cNvPr>
+          <p:cNvCxnSpPr>
+            <a:cxnSpLocks/>
+            <a:stCxn id="11" idx="0"/>
+            <a:endCxn id="16" idx="2"/>
+          </p:cNvCxnSpPr>
+          <p:nvPr/>
+        </p:nvCxnSpPr>
+        <p:spPr>
+          <a:xfrm flipV="1">
+            <a:off x="3200400" y="4434840"/>
+            <a:ext cx="0" cy="467360"/>
+          </a:xfrm>
+          <a:prstGeom prst="straightConnector1">
+            <a:avLst/>
+          </a:prstGeom>
+          <a:ln>
+            <a:tailEnd type="triangle"/>
+          </a:ln>
+        </p:spPr>
+        <p:style>
+          <a:lnRef idx="1">
+            <a:schemeClr val="accent1"/>
+          </a:lnRef>
+          <a:fillRef idx="0">
+            <a:schemeClr val="accent1"/>
+          </a:fillRef>
+          <a:effectRef idx="0">
+            <a:schemeClr val="accent1"/>
+          </a:effectRef>
+          <a:fontRef idx="minor">
+            <a:schemeClr val="tx1"/>
+          </a:fontRef>
+        </p:style>
+      </p:cxnSp>
+      <p:cxnSp>
+        <p:nvCxnSpPr>
+          <p:cNvPr id="57" name="直線矢印コネクタ 56">
+            <a:extLst>
+              <a:ext uri="{FF2B5EF4-FFF2-40B4-BE49-F238E27FC236}">
+                <a16:creationId xmlns:a16="http://schemas.microsoft.com/office/drawing/2014/main" id="{03F148F9-D11C-685C-FA27-AB408F2D696F}"/>
+              </a:ext>
+            </a:extLst>
+          </p:cNvPr>
+          <p:cNvCxnSpPr>
+            <a:stCxn id="9" idx="2"/>
+            <a:endCxn id="19" idx="0"/>
+          </p:cNvCxnSpPr>
+          <p:nvPr/>
+        </p:nvCxnSpPr>
+        <p:spPr>
+          <a:xfrm>
+            <a:off x="9600438" y="2843784"/>
+            <a:ext cx="0" cy="509016"/>
+          </a:xfrm>
+          <a:prstGeom prst="straightConnector1">
+            <a:avLst/>
+          </a:prstGeom>
+          <a:ln>
+            <a:tailEnd type="triangle"/>
+          </a:ln>
+        </p:spPr>
+        <p:style>
+          <a:lnRef idx="1">
+            <a:schemeClr val="accent1"/>
+          </a:lnRef>
+          <a:fillRef idx="0">
+            <a:schemeClr val="accent1"/>
+          </a:fillRef>
+          <a:effectRef idx="0">
+            <a:schemeClr val="accent1"/>
+          </a:effectRef>
+          <a:fontRef idx="minor">
+            <a:schemeClr val="tx1"/>
+          </a:fontRef>
+        </p:style>
+      </p:cxnSp>
+      <p:cxnSp>
+        <p:nvCxnSpPr>
+          <p:cNvPr id="59" name="直線矢印コネクタ 58">
+            <a:extLst>
+              <a:ext uri="{FF2B5EF4-FFF2-40B4-BE49-F238E27FC236}">
+                <a16:creationId xmlns:a16="http://schemas.microsoft.com/office/drawing/2014/main" id="{A7C389F8-1333-BF0F-2028-B2E6E68C5D3A}"/>
+              </a:ext>
+            </a:extLst>
+          </p:cNvPr>
+          <p:cNvCxnSpPr>
+            <a:cxnSpLocks/>
+            <a:stCxn id="14" idx="0"/>
+            <a:endCxn id="19" idx="2"/>
+          </p:cNvCxnSpPr>
+          <p:nvPr/>
+        </p:nvCxnSpPr>
+        <p:spPr>
+          <a:xfrm flipH="1" flipV="1">
+            <a:off x="9600438" y="4358640"/>
+            <a:ext cx="762" cy="543560"/>
+          </a:xfrm>
+          <a:prstGeom prst="straightConnector1">
+            <a:avLst/>
+          </a:prstGeom>
+          <a:ln>
+            <a:tailEnd type="triangle"/>
+          </a:ln>
+        </p:spPr>
+        <p:style>
+          <a:lnRef idx="1">
+            <a:schemeClr val="accent1"/>
+          </a:lnRef>
+          <a:fillRef idx="0">
+            <a:schemeClr val="accent1"/>
+          </a:fillRef>
+          <a:effectRef idx="0">
+            <a:schemeClr val="accent1"/>
+          </a:effectRef>
+          <a:fontRef idx="minor">
+            <a:schemeClr val="tx1"/>
+          </a:fontRef>
+        </p:style>
+      </p:cxnSp>
+      <p:sp>
+        <p:nvSpPr>
+          <p:cNvPr id="81" name="円弧 80">
+            <a:extLst>
+              <a:ext uri="{FF2B5EF4-FFF2-40B4-BE49-F238E27FC236}">
+                <a16:creationId xmlns:a16="http://schemas.microsoft.com/office/drawing/2014/main" id="{53BE7B37-34A3-D993-B5CF-D3B54B49DFDF}"/>
+              </a:ext>
+            </a:extLst>
+          </p:cNvPr>
+          <p:cNvSpPr/>
+          <p:nvPr/>
+        </p:nvSpPr>
+        <p:spPr>
+          <a:xfrm rot="10800000">
+            <a:off x="6781800" y="5181600"/>
+            <a:ext cx="3352800" cy="929640"/>
+          </a:xfrm>
+          <a:prstGeom prst="arc">
+            <a:avLst>
+              <a:gd name="adj1" fmla="val 10795121"/>
+              <a:gd name="adj2" fmla="val 0"/>
+            </a:avLst>
+          </a:prstGeom>
+          <a:ln w="19050">
+            <a:headEnd type="triangle" w="med" len="med"/>
+            <a:tailEnd type="none" w="med" len="med"/>
+          </a:ln>
+        </p:spPr>
+        <p:style>
+          <a:lnRef idx="1">
+            <a:schemeClr val="accent1"/>
+          </a:lnRef>
+          <a:fillRef idx="0">
+            <a:schemeClr val="accent1"/>
+          </a:fillRef>
+          <a:effectRef idx="0">
+            <a:schemeClr val="accent1"/>
+          </a:effectRef>
+          <a:fontRef idx="minor">
+            <a:schemeClr val="tx1"/>
+          </a:fontRef>
+        </p:style>
+        <p:txBody>
+          <a:bodyPr rtlCol="0" anchor="ctr"/>
+          <a:lstStyle/>
+          <a:p>
+            <a:pPr algn="ctr"/>
+            <a:endParaRPr kumimoji="1" lang="ja-JP" altLang="en-US"/>
           </a:p>
         </p:txBody>
       </p:sp>
@@ -4808,32 +4439,7 @@
           </a:ln>
         </p:spPr>
         <p:txBody>
-          <a:bodyPr/>
-          <a:lstStyle/>
-          <a:p>
-            <a:endParaRPr lang="ja-JP" altLang="en-US"/>
-          </a:p>
-        </p:txBody>
-      </p:sp>
-      <p:sp>
-        <p:nvSpPr>
-          <p:cNvPr id="5" name="Text 3"/>
-          <p:cNvSpPr/>
-          <p:nvPr/>
-        </p:nvSpPr>
-        <p:spPr>
-          <a:xfrm>
-            <a:off x="649224" y="2130552"/>
-            <a:ext cx="1764792" cy="338328"/>
-          </a:xfrm>
-          <a:prstGeom prst="rect">
-            <a:avLst/>
-          </a:prstGeom>
-          <a:noFill/>
-          <a:ln/>
-        </p:spPr>
-        <p:txBody>
-          <a:bodyPr wrap="square" lIns="0" tIns="0" rIns="0" bIns="0" rtlCol="0" anchor="ctr">
+          <a:bodyPr wrap="square" lIns="91440" tIns="45720" rIns="91440" bIns="45720" anchor="ctr">
             <a:normAutofit/>
           </a:bodyPr>
           <a:lstStyle/>
@@ -4842,7 +4448,7 @@
               <a:buNone/>
             </a:pPr>
             <a:r>
-              <a:rPr lang="en-US" sz="1800" b="1" dirty="0">
+              <a:rPr lang="en-US" sz="1800" b="1">
                 <a:solidFill>
                   <a:srgbClr val="1F4E79"/>
                 </a:solidFill>
@@ -4852,38 +4458,14 @@
               </a:rPr>
               <a:t>① 測定</a:t>
             </a:r>
-            <a:endParaRPr lang="en-US" sz="1800" dirty="0"/>
-          </a:p>
-        </p:txBody>
-      </p:sp>
-      <p:sp>
-        <p:nvSpPr>
-          <p:cNvPr id="6" name="Text 4"/>
-          <p:cNvSpPr/>
-          <p:nvPr/>
-        </p:nvSpPr>
-        <p:spPr>
-          <a:xfrm>
-            <a:off x="649224" y="2660904"/>
-            <a:ext cx="1764792" cy="502920"/>
-          </a:xfrm>
-          <a:prstGeom prst="rect">
-            <a:avLst/>
-          </a:prstGeom>
-          <a:noFill/>
-          <a:ln/>
-        </p:spPr>
-        <p:txBody>
-          <a:bodyPr wrap="square" lIns="254" tIns="254" rIns="254" bIns="254" rtlCol="0" anchor="ctr">
-            <a:normAutofit/>
-          </a:bodyPr>
-          <a:lstStyle/>
+            <a:endParaRPr lang="en-US" sz="1800"/>
+          </a:p>
           <a:p>
             <a:pPr marL="0" indent="0" algn="ctr">
               <a:buNone/>
             </a:pPr>
             <a:r>
-              <a:rPr lang="en-US" sz="1450" dirty="0" err="1">
+              <a:rPr lang="en-US" sz="1450" err="1">
                 <a:solidFill>
                   <a:srgbClr val="202124"/>
                 </a:solidFill>
@@ -4893,7 +4475,7 @@
               </a:rPr>
               <a:t>まず現状を数値で</a:t>
             </a:r>
-            <a:endParaRPr lang="en-US" sz="1450" dirty="0">
+            <a:endParaRPr lang="en-US" sz="1450">
               <a:solidFill>
                 <a:srgbClr val="202124"/>
               </a:solidFill>
@@ -4907,7 +4489,7 @@
               <a:buNone/>
             </a:pPr>
             <a:r>
-              <a:rPr lang="en-US" sz="1450" dirty="0" err="1">
+              <a:rPr lang="en-US" sz="1450" err="1">
                 <a:solidFill>
                   <a:srgbClr val="202124"/>
                 </a:solidFill>
@@ -4917,7 +4499,7 @@
               </a:rPr>
               <a:t>確認</a:t>
             </a:r>
-            <a:endParaRPr lang="en-US" sz="1450" dirty="0"/>
+            <a:endParaRPr lang="en-US" sz="1450"/>
           </a:p>
         </p:txBody>
       </p:sp>
@@ -4980,32 +4562,7 @@
           </a:ln>
         </p:spPr>
         <p:txBody>
-          <a:bodyPr/>
-          <a:lstStyle/>
-          <a:p>
-            <a:endParaRPr lang="ja-JP" altLang="en-US"/>
-          </a:p>
-        </p:txBody>
-      </p:sp>
-      <p:sp>
-        <p:nvSpPr>
-          <p:cNvPr id="9" name="Text 7"/>
-          <p:cNvSpPr/>
-          <p:nvPr/>
-        </p:nvSpPr>
-        <p:spPr>
-          <a:xfrm>
-            <a:off x="2962656" y="2130552"/>
-            <a:ext cx="1764792" cy="338328"/>
-          </a:xfrm>
-          <a:prstGeom prst="rect">
-            <a:avLst/>
-          </a:prstGeom>
-          <a:noFill/>
-          <a:ln/>
-        </p:spPr>
-        <p:txBody>
-          <a:bodyPr wrap="square" lIns="0" tIns="0" rIns="0" bIns="0" rtlCol="0" anchor="ctr">
+          <a:bodyPr wrap="square" lIns="91440" tIns="45720" rIns="91440" bIns="45720" anchor="ctr">
             <a:normAutofit/>
           </a:bodyPr>
           <a:lstStyle/>
@@ -5014,7 +4571,7 @@
               <a:buNone/>
             </a:pPr>
             <a:r>
-              <a:rPr lang="en-US" sz="1800" b="1" dirty="0">
+              <a:rPr lang="en-US" sz="1800" b="1">
                 <a:solidFill>
                   <a:srgbClr val="1F4E79"/>
                 </a:solidFill>
@@ -5024,38 +4581,14 @@
               </a:rPr>
               <a:t>② 問題を絞る</a:t>
             </a:r>
-            <a:endParaRPr lang="en-US" sz="1800" dirty="0"/>
-          </a:p>
-        </p:txBody>
-      </p:sp>
-      <p:sp>
-        <p:nvSpPr>
-          <p:cNvPr id="10" name="Text 8"/>
-          <p:cNvSpPr/>
-          <p:nvPr/>
-        </p:nvSpPr>
-        <p:spPr>
-          <a:xfrm>
-            <a:off x="2962656" y="2660904"/>
-            <a:ext cx="1764792" cy="502920"/>
-          </a:xfrm>
-          <a:prstGeom prst="rect">
-            <a:avLst/>
-          </a:prstGeom>
-          <a:noFill/>
-          <a:ln/>
-        </p:spPr>
-        <p:txBody>
-          <a:bodyPr wrap="square" lIns="254" tIns="254" rIns="254" bIns="254" rtlCol="0" anchor="ctr">
-            <a:normAutofit/>
-          </a:bodyPr>
-          <a:lstStyle/>
+            <a:endParaRPr lang="en-US" sz="1800"/>
+          </a:p>
           <a:p>
             <a:pPr marL="0" indent="0" algn="ctr">
               <a:buNone/>
             </a:pPr>
             <a:r>
-              <a:rPr lang="en-US" sz="1450" dirty="0">
+              <a:rPr lang="en-US" sz="1450">
                 <a:solidFill>
                   <a:srgbClr val="202124"/>
                 </a:solidFill>
@@ -5065,7 +4598,7 @@
               </a:rPr>
               <a:t>どんな誤りが多いかを見る</a:t>
             </a:r>
-            <a:endParaRPr lang="en-US" sz="1450" dirty="0"/>
+            <a:endParaRPr lang="en-US" sz="1450"/>
           </a:p>
         </p:txBody>
       </p:sp>
@@ -5128,32 +4661,7 @@
           </a:ln>
         </p:spPr>
         <p:txBody>
-          <a:bodyPr/>
-          <a:lstStyle/>
-          <a:p>
-            <a:endParaRPr lang="ja-JP" altLang="en-US"/>
-          </a:p>
-        </p:txBody>
-      </p:sp>
-      <p:sp>
-        <p:nvSpPr>
-          <p:cNvPr id="13" name="Text 11"/>
-          <p:cNvSpPr/>
-          <p:nvPr/>
-        </p:nvSpPr>
-        <p:spPr>
-          <a:xfrm>
-            <a:off x="5209103" y="2130552"/>
-            <a:ext cx="1831777" cy="338328"/>
-          </a:xfrm>
-          <a:prstGeom prst="rect">
-            <a:avLst/>
-          </a:prstGeom>
-          <a:noFill/>
-          <a:ln/>
-        </p:spPr>
-        <p:txBody>
-          <a:bodyPr wrap="square" lIns="0" tIns="0" rIns="0" bIns="0" rtlCol="0" anchor="ctr">
+          <a:bodyPr wrap="square" lIns="91440" tIns="45720" rIns="91440" bIns="45720" anchor="ctr">
             <a:normAutofit/>
           </a:bodyPr>
           <a:lstStyle/>
@@ -5162,7 +4670,7 @@
               <a:buNone/>
             </a:pPr>
             <a:r>
-              <a:rPr lang="en-US" sz="1800" b="1" dirty="0">
+              <a:rPr lang="en-US" sz="1800" b="1">
                 <a:solidFill>
                   <a:srgbClr val="C55A11"/>
                 </a:solidFill>
@@ -5172,38 +4680,14 @@
               </a:rPr>
               <a:t>③ 1項目だけ変更</a:t>
             </a:r>
-            <a:endParaRPr lang="en-US" sz="1800" dirty="0"/>
-          </a:p>
-        </p:txBody>
-      </p:sp>
-      <p:sp>
-        <p:nvSpPr>
-          <p:cNvPr id="14" name="Text 12"/>
-          <p:cNvSpPr/>
-          <p:nvPr/>
-        </p:nvSpPr>
-        <p:spPr>
-          <a:xfrm>
-            <a:off x="5276088" y="2660904"/>
-            <a:ext cx="1764792" cy="502920"/>
-          </a:xfrm>
-          <a:prstGeom prst="rect">
-            <a:avLst/>
-          </a:prstGeom>
-          <a:noFill/>
-          <a:ln/>
-        </p:spPr>
-        <p:txBody>
-          <a:bodyPr wrap="square" lIns="254" tIns="254" rIns="254" bIns="254" rtlCol="0" anchor="ctr">
-            <a:normAutofit/>
-          </a:bodyPr>
-          <a:lstStyle/>
+            <a:endParaRPr lang="en-US" sz="1800"/>
+          </a:p>
           <a:p>
             <a:pPr marL="0" indent="0" algn="ctr">
               <a:buNone/>
             </a:pPr>
             <a:r>
-              <a:rPr lang="en-US" sz="1450" dirty="0">
+              <a:rPr lang="en-US" sz="1450">
                 <a:solidFill>
                   <a:srgbClr val="202124"/>
                 </a:solidFill>
@@ -5213,7 +4697,7 @@
               </a:rPr>
               <a:t>再学習・位置・背景など</a:t>
             </a:r>
-            <a:endParaRPr lang="en-US" sz="1450" dirty="0"/>
+            <a:endParaRPr lang="en-US" sz="1450"/>
           </a:p>
         </p:txBody>
       </p:sp>
@@ -5276,32 +4760,7 @@
           </a:ln>
         </p:spPr>
         <p:txBody>
-          <a:bodyPr/>
-          <a:lstStyle/>
-          <a:p>
-            <a:endParaRPr lang="ja-JP" altLang="en-US"/>
-          </a:p>
-        </p:txBody>
-      </p:sp>
-      <p:sp>
-        <p:nvSpPr>
-          <p:cNvPr id="17" name="Text 15"/>
-          <p:cNvSpPr/>
-          <p:nvPr/>
-        </p:nvSpPr>
-        <p:spPr>
-          <a:xfrm>
-            <a:off x="7589520" y="2130552"/>
-            <a:ext cx="1764792" cy="338328"/>
-          </a:xfrm>
-          <a:prstGeom prst="rect">
-            <a:avLst/>
-          </a:prstGeom>
-          <a:noFill/>
-          <a:ln/>
-        </p:spPr>
-        <p:txBody>
-          <a:bodyPr wrap="square" lIns="0" tIns="0" rIns="0" bIns="0" rtlCol="0" anchor="ctr">
+          <a:bodyPr wrap="square" lIns="91440" tIns="45720" rIns="91440" bIns="45720" anchor="ctr">
             <a:normAutofit/>
           </a:bodyPr>
           <a:lstStyle/>
@@ -5310,7 +4769,7 @@
               <a:buNone/>
             </a:pPr>
             <a:r>
-              <a:rPr lang="en-US" sz="1800" b="1" dirty="0">
+              <a:rPr lang="en-US" sz="1800" b="1">
                 <a:solidFill>
                   <a:srgbClr val="1F4E79"/>
                 </a:solidFill>
@@ -5320,38 +4779,14 @@
               </a:rPr>
               <a:t>④ 再測定</a:t>
             </a:r>
-            <a:endParaRPr lang="en-US" sz="1800" dirty="0"/>
-          </a:p>
-        </p:txBody>
-      </p:sp>
-      <p:sp>
-        <p:nvSpPr>
-          <p:cNvPr id="18" name="Text 16"/>
-          <p:cNvSpPr/>
-          <p:nvPr/>
-        </p:nvSpPr>
-        <p:spPr>
-          <a:xfrm>
-            <a:off x="7589520" y="2660904"/>
-            <a:ext cx="1764792" cy="502920"/>
-          </a:xfrm>
-          <a:prstGeom prst="rect">
-            <a:avLst/>
-          </a:prstGeom>
-          <a:noFill/>
-          <a:ln/>
-        </p:spPr>
-        <p:txBody>
-          <a:bodyPr wrap="square" lIns="254" tIns="254" rIns="254" bIns="254" rtlCol="0" anchor="ctr">
-            <a:normAutofit/>
-          </a:bodyPr>
-          <a:lstStyle/>
+            <a:endParaRPr lang="en-US" sz="1800"/>
+          </a:p>
           <a:p>
             <a:pPr marL="0" indent="0" algn="ctr">
               <a:buNone/>
             </a:pPr>
             <a:r>
-              <a:rPr lang="en-US" sz="1450" dirty="0">
+              <a:rPr lang="en-US" sz="1450">
                 <a:solidFill>
                   <a:srgbClr val="202124"/>
                 </a:solidFill>
@@ -5361,7 +4796,7 @@
               </a:rPr>
               <a:t>同じ20回で比較</a:t>
             </a:r>
-            <a:endParaRPr lang="en-US" sz="1450" dirty="0"/>
+            <a:endParaRPr lang="en-US" sz="1450"/>
           </a:p>
         </p:txBody>
       </p:sp>
@@ -5424,32 +4859,7 @@
           </a:ln>
         </p:spPr>
         <p:txBody>
-          <a:bodyPr/>
-          <a:lstStyle/>
-          <a:p>
-            <a:endParaRPr lang="ja-JP" altLang="en-US"/>
-          </a:p>
-        </p:txBody>
-      </p:sp>
-      <p:sp>
-        <p:nvSpPr>
-          <p:cNvPr id="21" name="Text 19"/>
-          <p:cNvSpPr/>
-          <p:nvPr/>
-        </p:nvSpPr>
-        <p:spPr>
-          <a:xfrm>
-            <a:off x="9902952" y="2130552"/>
-            <a:ext cx="1764792" cy="338328"/>
-          </a:xfrm>
-          <a:prstGeom prst="rect">
-            <a:avLst/>
-          </a:prstGeom>
-          <a:noFill/>
-          <a:ln/>
-        </p:spPr>
-        <p:txBody>
-          <a:bodyPr wrap="square" lIns="0" tIns="0" rIns="0" bIns="0" rtlCol="0" anchor="ctr">
+          <a:bodyPr wrap="square" lIns="91440" tIns="45720" rIns="91440" bIns="45720" anchor="ctr">
             <a:normAutofit/>
           </a:bodyPr>
           <a:lstStyle/>
@@ -5458,7 +4868,7 @@
               <a:buNone/>
             </a:pPr>
             <a:r>
-              <a:rPr lang="en-US" sz="1800" b="1" dirty="0">
+              <a:rPr lang="en-US" sz="1800" b="1">
                 <a:solidFill>
                   <a:srgbClr val="1F4E79"/>
                 </a:solidFill>
@@ -5468,38 +4878,14 @@
               </a:rPr>
               <a:t>⑤ 比較・考察</a:t>
             </a:r>
-            <a:endParaRPr lang="en-US" sz="1800" dirty="0"/>
-          </a:p>
-        </p:txBody>
-      </p:sp>
-      <p:sp>
-        <p:nvSpPr>
-          <p:cNvPr id="22" name="Text 20"/>
-          <p:cNvSpPr/>
-          <p:nvPr/>
-        </p:nvSpPr>
-        <p:spPr>
-          <a:xfrm>
-            <a:off x="9902952" y="2660904"/>
-            <a:ext cx="1764792" cy="502920"/>
-          </a:xfrm>
-          <a:prstGeom prst="rect">
-            <a:avLst/>
-          </a:prstGeom>
-          <a:noFill/>
-          <a:ln/>
-        </p:spPr>
-        <p:txBody>
-          <a:bodyPr wrap="square" lIns="254" tIns="254" rIns="254" bIns="254" rtlCol="0" anchor="ctr">
-            <a:normAutofit/>
-          </a:bodyPr>
-          <a:lstStyle/>
+            <a:endParaRPr lang="en-US" sz="1800"/>
+          </a:p>
           <a:p>
             <a:pPr marL="0" indent="0" algn="ctr">
               <a:buNone/>
             </a:pPr>
             <a:r>
-              <a:rPr lang="en-US" sz="1450" dirty="0">
+              <a:rPr lang="en-US" sz="1450">
                 <a:solidFill>
                   <a:srgbClr val="202124"/>
                 </a:solidFill>
@@ -5509,7 +4895,7 @@
               </a:rPr>
               <a:t>次の手立てを考える</a:t>
             </a:r>
-            <a:endParaRPr lang="en-US" sz="1450" dirty="0"/>
+            <a:endParaRPr lang="en-US" sz="1450"/>
           </a:p>
         </p:txBody>
       </p:sp>
@@ -5540,71 +4926,7 @@
           </a:ln>
         </p:spPr>
         <p:txBody>
-          <a:bodyPr/>
-          <a:lstStyle/>
-          <a:p>
-            <a:endParaRPr lang="ja-JP" altLang="en-US"/>
-          </a:p>
-        </p:txBody>
-      </p:sp>
-      <p:sp>
-        <p:nvSpPr>
-          <p:cNvPr id="24" name="Text 22"/>
-          <p:cNvSpPr/>
-          <p:nvPr/>
-        </p:nvSpPr>
-        <p:spPr>
-          <a:xfrm>
-            <a:off x="891008" y="4080776"/>
-            <a:ext cx="2272178" cy="274320"/>
-          </a:xfrm>
-          <a:prstGeom prst="rect">
-            <a:avLst/>
-          </a:prstGeom>
-          <a:noFill/>
-          <a:ln/>
-        </p:spPr>
-        <p:txBody>
-          <a:bodyPr wrap="square" lIns="0" tIns="0" rIns="0" bIns="0" rtlCol="0" anchor="ctr"/>
-          <a:lstStyle/>
-          <a:p>
-            <a:pPr marL="0" indent="0">
-              <a:buNone/>
-            </a:pPr>
-            <a:r>
-              <a:rPr lang="en-US" sz="1800" b="1" dirty="0">
-                <a:solidFill>
-                  <a:srgbClr val="2F75B5"/>
-                </a:solidFill>
-                <a:latin typeface="Noto Sans CJK JP" pitchFamily="34" charset="0"/>
-                <a:ea typeface="Noto Sans CJK JP" pitchFamily="34" charset="-122"/>
-                <a:cs typeface="Noto Sans CJK JP" pitchFamily="34" charset="-120"/>
-              </a:rPr>
-              <a:t>打てる手立ての例</a:t>
-            </a:r>
-            <a:endParaRPr lang="en-US" sz="1800" dirty="0"/>
-          </a:p>
-        </p:txBody>
-      </p:sp>
-      <p:sp>
-        <p:nvSpPr>
-          <p:cNvPr id="25" name="Text 23"/>
-          <p:cNvSpPr/>
-          <p:nvPr/>
-        </p:nvSpPr>
-        <p:spPr>
-          <a:xfrm>
-            <a:off x="960120" y="4498848"/>
-            <a:ext cx="4663440" cy="594360"/>
-          </a:xfrm>
-          <a:prstGeom prst="rect">
-            <a:avLst/>
-          </a:prstGeom>
-          <a:noFill/>
-          <a:ln/>
-        </p:spPr>
-        <p:txBody>
-          <a:bodyPr wrap="square" lIns="0" tIns="0" rIns="0" bIns="0" rtlCol="0" anchor="ctr">
+          <a:bodyPr wrap="square" lIns="91440" tIns="45720" rIns="91440" bIns="45720" anchor="ctr">
             <a:normAutofit/>
           </a:bodyPr>
           <a:lstStyle/>
@@ -5613,7 +4935,24 @@
               <a:buNone/>
             </a:pPr>
             <a:r>
-              <a:rPr lang="en-US" sz="1500" dirty="0">
+              <a:rPr lang="en-US" sz="1800" b="1">
+                <a:solidFill>
+                  <a:srgbClr val="2F75B5"/>
+                </a:solidFill>
+                <a:latin typeface="Noto Sans CJK JP" pitchFamily="34" charset="0"/>
+                <a:ea typeface="Noto Sans CJK JP" pitchFamily="34" charset="-122"/>
+                <a:cs typeface="Noto Sans CJK JP" pitchFamily="34" charset="-120"/>
+              </a:rPr>
+              <a:t>打てる手立ての例</a:t>
+            </a:r>
+            <a:endParaRPr lang="en-US" sz="1800"/>
+          </a:p>
+          <a:p>
+            <a:pPr marL="0" indent="0">
+              <a:buNone/>
+            </a:pPr>
+            <a:r>
+              <a:rPr lang="en-US" sz="1500">
                 <a:solidFill>
                   <a:srgbClr val="202124"/>
                 </a:solidFill>
@@ -5623,14 +4962,14 @@
               </a:rPr>
               <a:t>再学習 / カメラ位置 / 背景 / 照明 / フォーカス</a:t>
             </a:r>
-            <a:endParaRPr lang="en-US" sz="1500" dirty="0"/>
+            <a:endParaRPr lang="en-US" sz="1500"/>
           </a:p>
           <a:p>
             <a:pPr marL="0" indent="0">
               <a:buNone/>
             </a:pPr>
             <a:r>
-              <a:rPr lang="en-US" sz="1500" dirty="0">
+              <a:rPr lang="en-US" sz="1500">
                 <a:solidFill>
                   <a:srgbClr val="202124"/>
                 </a:solidFill>
@@ -5640,7 +4979,7 @@
               </a:rPr>
               <a:t>IRセンサ位置・タイミング / 配線 / Relay・PLC確認</a:t>
             </a:r>
-            <a:endParaRPr lang="en-US" sz="1500" dirty="0"/>
+            <a:endParaRPr lang="en-US" sz="1500"/>
           </a:p>
         </p:txBody>
       </p:sp>
@@ -5671,32 +5010,7 @@
           </a:ln>
         </p:spPr>
         <p:txBody>
-          <a:bodyPr/>
-          <a:lstStyle/>
-          <a:p>
-            <a:endParaRPr lang="ja-JP" altLang="en-US"/>
-          </a:p>
-        </p:txBody>
-      </p:sp>
-      <p:sp>
-        <p:nvSpPr>
-          <p:cNvPr id="27" name="Text 25"/>
-          <p:cNvSpPr/>
-          <p:nvPr/>
-        </p:nvSpPr>
-        <p:spPr>
-          <a:xfrm>
-            <a:off x="6449710" y="4080776"/>
-            <a:ext cx="4754880" cy="274320"/>
-          </a:xfrm>
-          <a:prstGeom prst="rect">
-            <a:avLst/>
-          </a:prstGeom>
-          <a:noFill/>
-          <a:ln/>
-        </p:spPr>
-        <p:txBody>
-          <a:bodyPr wrap="square" lIns="0" tIns="0" rIns="0" bIns="0" rtlCol="0" anchor="ctr">
+          <a:bodyPr wrap="square" lIns="91440" tIns="45720" rIns="91440" bIns="45720" anchor="ctr">
             <a:normAutofit/>
           </a:bodyPr>
           <a:lstStyle/>
@@ -5705,7 +5019,7 @@
               <a:buNone/>
             </a:pPr>
             <a:r>
-              <a:rPr lang="en-US" sz="1800" b="1" dirty="0">
+              <a:rPr lang="en-US" sz="1800" b="1">
                 <a:solidFill>
                   <a:srgbClr val="2E7D32"/>
                 </a:solidFill>
@@ -5715,38 +5029,14 @@
               </a:rPr>
               <a:t>結果が悪化しても「失敗」とは限らない</a:t>
             </a:r>
-            <a:endParaRPr lang="en-US" sz="1800" dirty="0"/>
-          </a:p>
-        </p:txBody>
-      </p:sp>
-      <p:sp>
-        <p:nvSpPr>
-          <p:cNvPr id="28" name="Text 26"/>
-          <p:cNvSpPr/>
-          <p:nvPr/>
-        </p:nvSpPr>
-        <p:spPr>
-          <a:xfrm>
-            <a:off x="6492240" y="4526280"/>
-            <a:ext cx="4754880" cy="493776"/>
-          </a:xfrm>
-          <a:prstGeom prst="rect">
-            <a:avLst/>
-          </a:prstGeom>
-          <a:noFill/>
-          <a:ln/>
-        </p:spPr>
-        <p:txBody>
-          <a:bodyPr wrap="square" lIns="0" tIns="0" rIns="0" bIns="0" rtlCol="0" anchor="ctr">
-            <a:normAutofit/>
-          </a:bodyPr>
-          <a:lstStyle/>
+            <a:endParaRPr lang="en-US" sz="1800"/>
+          </a:p>
           <a:p>
             <a:pPr marL="0" indent="0">
               <a:buNone/>
             </a:pPr>
             <a:r>
-              <a:rPr lang="en-US" sz="1550" dirty="0">
+              <a:rPr lang="en-US" sz="1550">
                 <a:solidFill>
                   <a:srgbClr val="202124"/>
                 </a:solidFill>
@@ -5756,7 +5046,7 @@
               </a:rPr>
               <a:t>変更と結果の関係が分かれば、それも次の改善につながる実験結果です。</a:t>
             </a:r>
-            <a:endParaRPr lang="en-US" sz="1550" dirty="0"/>
+            <a:endParaRPr lang="en-US" sz="1550"/>
           </a:p>
         </p:txBody>
       </p:sp>
@@ -5787,33 +5077,8 @@
           </a:ln>
         </p:spPr>
         <p:txBody>
-          <a:bodyPr/>
-          <a:lstStyle/>
-          <a:p>
-            <a:endParaRPr lang="ja-JP" altLang="en-US"/>
-          </a:p>
-        </p:txBody>
-      </p:sp>
-      <p:sp>
-        <p:nvSpPr>
-          <p:cNvPr id="30" name="Text 28"/>
-          <p:cNvSpPr/>
-          <p:nvPr/>
-        </p:nvSpPr>
-        <p:spPr>
-          <a:xfrm>
-            <a:off x="1234440" y="5550195"/>
-            <a:ext cx="9646920" cy="494414"/>
-          </a:xfrm>
-          <a:prstGeom prst="rect">
-            <a:avLst/>
-          </a:prstGeom>
-          <a:noFill/>
-          <a:ln/>
-        </p:spPr>
-        <p:txBody>
-          <a:bodyPr wrap="square" lIns="0" tIns="0" rIns="0" bIns="0" rtlCol="0" anchor="ctr">
-            <a:normAutofit fontScale="92500" lnSpcReduction="10000"/>
+          <a:bodyPr wrap="square" lIns="91440" tIns="45720" rIns="91440" bIns="45720" anchor="ctr">
+            <a:normAutofit fontScale="92500" lnSpcReduction="20000"/>
           </a:bodyPr>
           <a:lstStyle/>
           <a:p>
@@ -5821,7 +5086,7 @@
               <a:buNone/>
             </a:pPr>
             <a:r>
-              <a:rPr lang="en-US" sz="1900" b="1" dirty="0">
+              <a:rPr lang="en-US" sz="1900" b="1">
                 <a:solidFill>
                   <a:srgbClr val="1F4E79"/>
                 </a:solidFill>
@@ -5837,7 +5102,7 @@
               <a:buNone/>
             </a:pPr>
             <a:r>
-              <a:rPr lang="en-US" sz="1900" b="1" dirty="0" err="1">
+              <a:rPr lang="en-US" sz="1900" b="1" err="1">
                 <a:solidFill>
                   <a:srgbClr val="1F4E79"/>
                 </a:solidFill>
@@ -5848,7 +5113,7 @@
               <a:t>システムを観察し、根拠をもって改善すること</a:t>
             </a:r>
             <a:r>
-              <a:rPr lang="en-US" sz="1900" b="1" dirty="0">
+              <a:rPr lang="en-US" sz="1900" b="1">
                 <a:solidFill>
                   <a:srgbClr val="1F4E79"/>
                 </a:solidFill>
@@ -5858,7 +5123,7 @@
               </a:rPr>
               <a:t>。</a:t>
             </a:r>
-            <a:endParaRPr lang="en-US" sz="1900" dirty="0"/>
+            <a:endParaRPr lang="en-US" sz="1900"/>
           </a:p>
         </p:txBody>
       </p:sp>
@@ -5882,7 +5147,7 @@
           </a:prstGeom>
           <a:extLst>
             <a:ext uri="{C572A759-6A51-4108-AA02-DFA0A04FC94B}">
-              <ma14:wrappingTextBoxFlag xmlns:ma14="http://schemas.microsoft.com/office/mac/drawingml/2011/main" xmlns="" val="0"/>
+              <ma14:wrappingTextBoxFlag xmlns="" xmlns:ma14="http://schemas.microsoft.com/office/mac/drawingml/2011/main" val="0"/>
             </a:ext>
           </a:extLst>
         </p:spPr>

</xml_diff>